<commit_message>
Fix: Slides 8-9-10 now match class project PPT style exactly — same positions, font sizes, colors, card format, connector lines, chip layout
</commit_message>
<xml_diff>
--- a/ppt/Smart_Ambulance_v2.pptx
+++ b/ppt/Smart_Ambulance_v2.pptx
@@ -15,9 +15,10 @@
     <p:sldId id="263" r:id="rId9"/>
     <p:sldId id="264" r:id="rId10"/>
     <p:sldId id="265" r:id="rId11"/>
+    <p:sldId id="266" r:id="rId12"/>
   </p:sldIdLst>
   <p:notesMasterIdLst>
-    <p:notesMasterId r:id="rId12"/>
+    <p:notesMasterId r:id="rId13"/>
   </p:notesMasterIdLst>
   <p:sldSz cx="9144000" cy="5143500"/>
   <p:notesSz cx="5143500" cy="9144000"/>
@@ -641,6 +642,94 @@
 </p:notes>
 </file>
 
+<file path=ppt/notesSlides/notesSlide11.xml><?xml version="1.0" encoding="utf-8"?>
+<p:notes xmlns:a="http://schemas.openxmlformats.org/drawingml/2006/main" xmlns:r="http://schemas.openxmlformats.org/officeDocument/2006/relationships" xmlns:p="http://schemas.openxmlformats.org/presentationml/2006/main">
+  <p:cSld>
+    <p:spTree>
+      <p:nvGrpSpPr>
+        <p:cNvPr id="1" name=""/>
+        <p:cNvGrpSpPr/>
+        <p:nvPr/>
+      </p:nvGrpSpPr>
+      <p:grpSpPr>
+        <a:xfrm>
+          <a:off x="0" y="0"/>
+          <a:ext cx="0" cy="0"/>
+          <a:chOff x="0" y="0"/>
+          <a:chExt cx="0" cy="0"/>
+        </a:xfrm>
+      </p:grpSpPr>
+      <p:sp>
+        <p:nvSpPr>
+          <p:cNvPr id="2" name="Slide Image Placeholder 1"/>
+          <p:cNvSpPr>
+            <a:spLocks noGrp="1" noRot="1" noChangeAspect="1"/>
+          </p:cNvSpPr>
+          <p:nvPr>
+            <p:ph type="sldImg"/>
+          </p:nvPr>
+        </p:nvSpPr>
+        <p:spPr/>
+      </p:sp>
+      <p:sp>
+        <p:nvSpPr>
+          <p:cNvPr id="3" name="Notes Placeholder 2"/>
+          <p:cNvSpPr>
+            <a:spLocks noGrp="1"/>
+          </p:cNvSpPr>
+          <p:nvPr>
+            <p:ph type="body" idx="1"/>
+          </p:nvPr>
+        </p:nvSpPr>
+        <p:spPr/>
+        <p:txBody>
+          <a:bodyPr/>
+          <a:lstStyle/>
+          <a:p>
+            <a:r>
+              <a:rPr lang="en-US" dirty="0"/>
+              <a:t/>
+            </a:r>
+            <a:endParaRPr lang="en-US" dirty="0"/>
+          </a:p>
+        </p:txBody>
+      </p:sp>
+      <p:sp>
+        <p:nvSpPr>
+          <p:cNvPr id="4" name="Slide Number Placeholder 3"/>
+          <p:cNvSpPr>
+            <a:spLocks noGrp="1"/>
+          </p:cNvSpPr>
+          <p:nvPr>
+            <p:ph type="sldNum" sz="quarter" idx="10"/>
+          </p:nvPr>
+        </p:nvSpPr>
+        <p:spPr/>
+        <p:txBody>
+          <a:bodyPr/>
+          <a:lstStyle/>
+          <a:p>
+            <a:fld id="{F7021451-1387-4CA6-816F-3879F97B5CBC}" type="slidenum">
+              <a:rPr lang="en-US"/>
+              <a:t>11</a:t>
+            </a:fld>
+            <a:endParaRPr lang="en-US"/>
+          </a:p>
+        </p:txBody>
+      </p:sp>
+    </p:spTree>
+    <p:extLst>
+      <p:ext uri="{BB962C8B-B14F-4D97-AF65-F5344CB8AC3E}">
+        <p14:creationId xmlns:p14="http://schemas.microsoft.com/office/powerpoint/2010/main" val="1024086991"/>
+      </p:ext>
+    </p:extLst>
+  </p:cSld>
+  <p:clrMapOvr>
+    <a:masterClrMapping/>
+  </p:clrMapOvr>
+</p:notes>
+</file>
+
 <file path=ppt/notesSlides/notesSlide2.xml><?xml version="1.0" encoding="utf-8"?>
 <p:notes xmlns:a="http://schemas.openxmlformats.org/drawingml/2006/main" xmlns:r="http://schemas.openxmlformats.org/officeDocument/2006/relationships" xmlns:p="http://schemas.openxmlformats.org/presentationml/2006/main">
   <p:cSld>
@@ -2174,6 +2263,909 @@
     <p:bg>
       <p:bgPr>
         <a:solidFill>
+          <a:srgbClr val="F8FAFF"/>
+        </a:solidFill>
+      </p:bgPr>
+    </p:bg>
+    <p:spTree>
+      <p:nvGrpSpPr>
+        <p:cNvPr id="1" name=""/>
+        <p:cNvGrpSpPr/>
+        <p:nvPr/>
+      </p:nvGrpSpPr>
+      <p:grpSpPr>
+        <a:xfrm>
+          <a:off x="0" y="0"/>
+          <a:ext cx="0" cy="0"/>
+          <a:chOff x="0" y="0"/>
+          <a:chExt cx="0" cy="0"/>
+        </a:xfrm>
+      </p:grpSpPr>
+      <p:sp>
+        <p:nvSpPr>
+          <p:cNvPr id="2" name="Shape 0"/>
+          <p:cNvSpPr/>
+          <p:nvPr/>
+        </p:nvSpPr>
+        <p:spPr>
+          <a:xfrm>
+            <a:off x="0" y="0"/>
+            <a:ext cx="9144000" cy="1005840"/>
+          </a:xfrm>
+          <a:prstGeom prst="rect">
+            <a:avLst/>
+          </a:prstGeom>
+          <a:solidFill>
+            <a:srgbClr val="0B1D3A"/>
+          </a:solidFill>
+          <a:ln/>
+        </p:spPr>
+      </p:sp>
+      <p:sp>
+        <p:nvSpPr>
+          <p:cNvPr id="3" name="Shape 1"/>
+          <p:cNvSpPr/>
+          <p:nvPr/>
+        </p:nvSpPr>
+        <p:spPr>
+          <a:xfrm>
+            <a:off x="0" y="0"/>
+            <a:ext cx="164592" cy="5143500"/>
+          </a:xfrm>
+          <a:prstGeom prst="rect">
+            <a:avLst/>
+          </a:prstGeom>
+          <a:solidFill>
+            <a:srgbClr val="00B4D8"/>
+          </a:solidFill>
+          <a:ln/>
+        </p:spPr>
+      </p:sp>
+      <p:sp>
+        <p:nvSpPr>
+          <p:cNvPr id="4" name="Text 2"/>
+          <p:cNvSpPr/>
+          <p:nvPr/>
+        </p:nvSpPr>
+        <p:spPr>
+          <a:xfrm>
+            <a:off x="365760" y="91440"/>
+            <a:ext cx="8412480" cy="822960"/>
+          </a:xfrm>
+          <a:prstGeom prst="rect">
+            <a:avLst/>
+          </a:prstGeom>
+          <a:noFill/>
+          <a:ln/>
+        </p:spPr>
+        <p:txBody>
+          <a:bodyPr wrap="square" lIns="0" tIns="0" rIns="0" bIns="0" rtlCol="0" anchor="ctr"/>
+          <a:lstStyle/>
+          <a:p>
+            <a:pPr indent="0" marL="0">
+              <a:buNone/>
+            </a:pPr>
+            <a:r>
+              <a:rPr lang="en-US" sz="2400" b="1" dirty="0">
+                <a:solidFill>
+                  <a:srgbClr val="FFFFFF"/>
+                </a:solidFill>
+                <a:latin typeface="Calibri" pitchFamily="34" charset="0"/>
+                <a:ea typeface="Calibri" pitchFamily="34" charset="-122"/>
+                <a:cs typeface="Calibri" pitchFamily="34" charset="-120"/>
+              </a:rPr>
+              <a:t>3 Demo Cases to Explain During Presentation</a:t>
+            </a:r>
+            <a:endParaRPr lang="en-US" sz="2400" dirty="0"/>
+          </a:p>
+        </p:txBody>
+      </p:sp>
+      <p:sp>
+        <p:nvSpPr>
+          <p:cNvPr id="5" name="Shape 3"/>
+          <p:cNvSpPr/>
+          <p:nvPr/>
+        </p:nvSpPr>
+        <p:spPr>
+          <a:xfrm>
+            <a:off x="320040" y="1143000"/>
+            <a:ext cx="8503920" cy="1115568"/>
+          </a:xfrm>
+          <a:prstGeom prst="rect">
+            <a:avLst/>
+          </a:prstGeom>
+          <a:solidFill>
+            <a:srgbClr val="FFFFFF"/>
+          </a:solidFill>
+          <a:ln/>
+          <a:effectLst>
+            <a:outerShdw sx="100000" sy="100000" kx="0" ky="0" algn="bl" rotWithShape="0" blurRad="101600" dist="38100" dir="8100000">
+              <a:srgbClr val="000000">
+                <a:alpha val="12000"/>
+              </a:srgbClr>
+            </a:outerShdw>
+          </a:effectLst>
+        </p:spPr>
+      </p:sp>
+      <p:sp>
+        <p:nvSpPr>
+          <p:cNvPr id="6" name="Shape 4"/>
+          <p:cNvSpPr/>
+          <p:nvPr/>
+        </p:nvSpPr>
+        <p:spPr>
+          <a:xfrm>
+            <a:off x="320040" y="1143000"/>
+            <a:ext cx="658368" cy="1115568"/>
+          </a:xfrm>
+          <a:prstGeom prst="rect">
+            <a:avLst/>
+          </a:prstGeom>
+          <a:solidFill>
+            <a:srgbClr val="10B981"/>
+          </a:solidFill>
+          <a:ln/>
+        </p:spPr>
+      </p:sp>
+      <p:sp>
+        <p:nvSpPr>
+          <p:cNvPr id="7" name="Text 5"/>
+          <p:cNvSpPr/>
+          <p:nvPr/>
+        </p:nvSpPr>
+        <p:spPr>
+          <a:xfrm>
+            <a:off x="320040" y="1143000"/>
+            <a:ext cx="658368" cy="1115568"/>
+          </a:xfrm>
+          <a:prstGeom prst="rect">
+            <a:avLst/>
+          </a:prstGeom>
+          <a:noFill/>
+          <a:ln/>
+        </p:spPr>
+        <p:txBody>
+          <a:bodyPr wrap="square" lIns="0" tIns="0" rIns="0" bIns="0" rtlCol="0" anchor="ctr"/>
+          <a:lstStyle/>
+          <a:p>
+            <a:pPr algn="ctr" indent="0" marL="0">
+              <a:buNone/>
+            </a:pPr>
+            <a:r>
+              <a:rPr lang="en-US" sz="2800" b="1" dirty="0">
+                <a:solidFill>
+                  <a:srgbClr val="FFFFFF"/>
+                </a:solidFill>
+                <a:latin typeface="Calibri" pitchFamily="34" charset="0"/>
+                <a:ea typeface="Calibri" pitchFamily="34" charset="-122"/>
+                <a:cs typeface="Calibri" pitchFamily="34" charset="-120"/>
+              </a:rPr>
+              <a:t>01</a:t>
+            </a:r>
+            <a:endParaRPr lang="en-US" sz="2800" dirty="0"/>
+          </a:p>
+        </p:txBody>
+      </p:sp>
+      <p:sp>
+        <p:nvSpPr>
+          <p:cNvPr id="8" name="Text 6"/>
+          <p:cNvSpPr/>
+          <p:nvPr/>
+        </p:nvSpPr>
+        <p:spPr>
+          <a:xfrm>
+            <a:off x="1078992" y="1207008"/>
+            <a:ext cx="7205472" cy="274320"/>
+          </a:xfrm>
+          <a:prstGeom prst="rect">
+            <a:avLst/>
+          </a:prstGeom>
+          <a:noFill/>
+          <a:ln/>
+        </p:spPr>
+        <p:txBody>
+          <a:bodyPr wrap="square" lIns="0" tIns="0" rIns="0" bIns="0" rtlCol="0" anchor="ctr"/>
+          <a:lstStyle/>
+          <a:p>
+            <a:pPr indent="0" marL="0">
+              <a:buNone/>
+            </a:pPr>
+            <a:r>
+              <a:rPr lang="en-US" sz="1300" b="1" dirty="0">
+                <a:solidFill>
+                  <a:srgbClr val="1E293B"/>
+                </a:solidFill>
+                <a:latin typeface="Calibri" pitchFamily="34" charset="0"/>
+                <a:ea typeface="Calibri" pitchFamily="34" charset="-122"/>
+                <a:cs typeface="Calibri" pitchFamily="34" charset="-120"/>
+              </a:rPr>
+              <a:t>Nearest Hospital is Best — Simple Case</a:t>
+            </a:r>
+            <a:endParaRPr lang="en-US" sz="1300" dirty="0"/>
+          </a:p>
+        </p:txBody>
+      </p:sp>
+      <p:sp>
+        <p:nvSpPr>
+          <p:cNvPr id="9" name="Text 7"/>
+          <p:cNvSpPr/>
+          <p:nvPr/>
+        </p:nvSpPr>
+        <p:spPr>
+          <a:xfrm>
+            <a:off x="1078992" y="1481328"/>
+            <a:ext cx="7205472" cy="201168"/>
+          </a:xfrm>
+          <a:prstGeom prst="rect">
+            <a:avLst/>
+          </a:prstGeom>
+          <a:noFill/>
+          <a:ln/>
+        </p:spPr>
+        <p:txBody>
+          <a:bodyPr wrap="square" lIns="0" tIns="0" rIns="0" bIns="0" rtlCol="0" anchor="ctr"/>
+          <a:lstStyle/>
+          <a:p>
+            <a:pPr indent="0" marL="0">
+              <a:buNone/>
+            </a:pPr>
+            <a:r>
+              <a:rPr lang="en-US" sz="950" i="1" dirty="0">
+                <a:solidFill>
+                  <a:srgbClr val="64748B"/>
+                </a:solidFill>
+                <a:latin typeface="Calibri" pitchFamily="34" charset="0"/>
+                <a:ea typeface="Calibri" pitchFamily="34" charset="-122"/>
+                <a:cs typeface="Calibri" pitchFamily="34" charset="-120"/>
+              </a:rPr>
+              <a:t>Scenario: Patient at Node 1 (JSSATE)  |  Emergency: GENERAL  |  No ICU needed</a:t>
+            </a:r>
+            <a:endParaRPr lang="en-US" sz="950" dirty="0"/>
+          </a:p>
+        </p:txBody>
+      </p:sp>
+      <p:sp>
+        <p:nvSpPr>
+          <p:cNvPr id="10" name="Text 8"/>
+          <p:cNvSpPr/>
+          <p:nvPr/>
+        </p:nvSpPr>
+        <p:spPr>
+          <a:xfrm>
+            <a:off x="1078992" y="1682496"/>
+            <a:ext cx="5349240" cy="502920"/>
+          </a:xfrm>
+          <a:prstGeom prst="rect">
+            <a:avLst/>
+          </a:prstGeom>
+          <a:noFill/>
+          <a:ln/>
+        </p:spPr>
+        <p:txBody>
+          <a:bodyPr wrap="square" lIns="0" tIns="0" rIns="0" bIns="0" rtlCol="0" anchor="ctr"/>
+          <a:lstStyle/>
+          <a:p>
+            <a:pPr indent="0" marL="0">
+              <a:buNone/>
+            </a:pPr>
+            <a:r>
+              <a:rPr lang="en-US" sz="1000" dirty="0">
+                <a:solidFill>
+                  <a:srgbClr val="1E293B"/>
+                </a:solidFill>
+                <a:latin typeface="Calibri" pitchFamily="34" charset="0"/>
+                <a:ea typeface="Calibri" pitchFamily="34" charset="-122"/>
+                <a:cs typeface="Calibri" pitchFamily="34" charset="-120"/>
+              </a:rPr>
+              <a:t>Result: BGS Gleneagles (Node 5, 1.2 km) handles GENERAL, has beds, and is the shortest Dijkstra path. System correctly recommends it as PRIMARY.</a:t>
+            </a:r>
+            <a:endParaRPr lang="en-US" sz="1000" dirty="0"/>
+          </a:p>
+        </p:txBody>
+      </p:sp>
+      <p:sp>
+        <p:nvSpPr>
+          <p:cNvPr id="11" name="Shape 9"/>
+          <p:cNvSpPr/>
+          <p:nvPr/>
+        </p:nvSpPr>
+        <p:spPr>
+          <a:xfrm>
+            <a:off x="6565392" y="1645920"/>
+            <a:ext cx="2121408" cy="475488"/>
+          </a:xfrm>
+          <a:prstGeom prst="roundRect">
+            <a:avLst>
+              <a:gd name="adj" fmla="val 9615"/>
+            </a:avLst>
+          </a:prstGeom>
+          <a:solidFill>
+            <a:srgbClr val="10B981"/>
+          </a:solidFill>
+          <a:ln/>
+        </p:spPr>
+      </p:sp>
+      <p:sp>
+        <p:nvSpPr>
+          <p:cNvPr id="12" name="Text 10"/>
+          <p:cNvSpPr/>
+          <p:nvPr/>
+        </p:nvSpPr>
+        <p:spPr>
+          <a:xfrm>
+            <a:off x="6565392" y="1645920"/>
+            <a:ext cx="2121408" cy="475488"/>
+          </a:xfrm>
+          <a:prstGeom prst="rect">
+            <a:avLst/>
+          </a:prstGeom>
+          <a:noFill/>
+          <a:ln/>
+        </p:spPr>
+        <p:txBody>
+          <a:bodyPr wrap="square" lIns="38100" tIns="38100" rIns="38100" bIns="38100" rtlCol="0" anchor="ctr"/>
+          <a:lstStyle/>
+          <a:p>
+            <a:pPr algn="ctr" indent="0" marL="0">
+              <a:buNone/>
+            </a:pPr>
+            <a:r>
+              <a:rPr lang="en-US" sz="850" dirty="0">
+                <a:solidFill>
+                  <a:srgbClr val="FFFFFF"/>
+                </a:solidFill>
+                <a:latin typeface="Calibri" pitchFamily="34" charset="0"/>
+                <a:ea typeface="Calibri" pitchFamily="34" charset="-122"/>
+                <a:cs typeface="Calibri" pitchFamily="34" charset="-120"/>
+              </a:rPr>
+              <a:t>System works in the simple case — nearest IS best here.</a:t>
+            </a:r>
+            <a:endParaRPr lang="en-US" sz="850" dirty="0"/>
+          </a:p>
+        </p:txBody>
+      </p:sp>
+      <p:sp>
+        <p:nvSpPr>
+          <p:cNvPr id="13" name="Shape 11"/>
+          <p:cNvSpPr/>
+          <p:nvPr/>
+        </p:nvSpPr>
+        <p:spPr>
+          <a:xfrm>
+            <a:off x="320040" y="2404872"/>
+            <a:ext cx="8503920" cy="1115568"/>
+          </a:xfrm>
+          <a:prstGeom prst="rect">
+            <a:avLst/>
+          </a:prstGeom>
+          <a:solidFill>
+            <a:srgbClr val="FFFFFF"/>
+          </a:solidFill>
+          <a:ln/>
+          <a:effectLst>
+            <a:outerShdw sx="100000" sy="100000" kx="0" ky="0" algn="bl" rotWithShape="0" blurRad="101600" dist="38100" dir="8100000">
+              <a:srgbClr val="000000">
+                <a:alpha val="12000"/>
+              </a:srgbClr>
+            </a:outerShdw>
+          </a:effectLst>
+        </p:spPr>
+      </p:sp>
+      <p:sp>
+        <p:nvSpPr>
+          <p:cNvPr id="14" name="Shape 12"/>
+          <p:cNvSpPr/>
+          <p:nvPr/>
+        </p:nvSpPr>
+        <p:spPr>
+          <a:xfrm>
+            <a:off x="320040" y="2404872"/>
+            <a:ext cx="658368" cy="1115568"/>
+          </a:xfrm>
+          <a:prstGeom prst="rect">
+            <a:avLst/>
+          </a:prstGeom>
+          <a:solidFill>
+            <a:srgbClr val="F59E0B"/>
+          </a:solidFill>
+          <a:ln/>
+        </p:spPr>
+      </p:sp>
+      <p:sp>
+        <p:nvSpPr>
+          <p:cNvPr id="15" name="Text 13"/>
+          <p:cNvSpPr/>
+          <p:nvPr/>
+        </p:nvSpPr>
+        <p:spPr>
+          <a:xfrm>
+            <a:off x="320040" y="2404872"/>
+            <a:ext cx="658368" cy="1115568"/>
+          </a:xfrm>
+          <a:prstGeom prst="rect">
+            <a:avLst/>
+          </a:prstGeom>
+          <a:noFill/>
+          <a:ln/>
+        </p:spPr>
+        <p:txBody>
+          <a:bodyPr wrap="square" lIns="0" tIns="0" rIns="0" bIns="0" rtlCol="0" anchor="ctr"/>
+          <a:lstStyle/>
+          <a:p>
+            <a:pPr algn="ctr" indent="0" marL="0">
+              <a:buNone/>
+            </a:pPr>
+            <a:r>
+              <a:rPr lang="en-US" sz="2800" b="1" dirty="0">
+                <a:solidFill>
+                  <a:srgbClr val="FFFFFF"/>
+                </a:solidFill>
+                <a:latin typeface="Calibri" pitchFamily="34" charset="0"/>
+                <a:ea typeface="Calibri" pitchFamily="34" charset="-122"/>
+                <a:cs typeface="Calibri" pitchFamily="34" charset="-120"/>
+              </a:rPr>
+              <a:t>02</a:t>
+            </a:r>
+            <a:endParaRPr lang="en-US" sz="2800" dirty="0"/>
+          </a:p>
+        </p:txBody>
+      </p:sp>
+      <p:sp>
+        <p:nvSpPr>
+          <p:cNvPr id="16" name="Text 14"/>
+          <p:cNvSpPr/>
+          <p:nvPr/>
+        </p:nvSpPr>
+        <p:spPr>
+          <a:xfrm>
+            <a:off x="1078992" y="2468880"/>
+            <a:ext cx="7205472" cy="274320"/>
+          </a:xfrm>
+          <a:prstGeom prst="rect">
+            <a:avLst/>
+          </a:prstGeom>
+          <a:noFill/>
+          <a:ln/>
+        </p:spPr>
+        <p:txBody>
+          <a:bodyPr wrap="square" lIns="0" tIns="0" rIns="0" bIns="0" rtlCol="0" anchor="ctr"/>
+          <a:lstStyle/>
+          <a:p>
+            <a:pPr indent="0" marL="0">
+              <a:buNone/>
+            </a:pPr>
+            <a:r>
+              <a:rPr lang="en-US" sz="1300" b="1" dirty="0">
+                <a:solidFill>
+                  <a:srgbClr val="1E293B"/>
+                </a:solidFill>
+                <a:latin typeface="Calibri" pitchFamily="34" charset="0"/>
+                <a:ea typeface="Calibri" pitchFamily="34" charset="-122"/>
+                <a:cs typeface="Calibri" pitchFamily="34" charset="-120"/>
+              </a:rPr>
+              <a:t>Nearest Hospital Lacks Specialization — Filtered Out</a:t>
+            </a:r>
+            <a:endParaRPr lang="en-US" sz="1300" dirty="0"/>
+          </a:p>
+        </p:txBody>
+      </p:sp>
+      <p:sp>
+        <p:nvSpPr>
+          <p:cNvPr id="17" name="Text 15"/>
+          <p:cNvSpPr/>
+          <p:nvPr/>
+        </p:nvSpPr>
+        <p:spPr>
+          <a:xfrm>
+            <a:off x="1078992" y="2743200"/>
+            <a:ext cx="7205472" cy="201168"/>
+          </a:xfrm>
+          <a:prstGeom prst="rect">
+            <a:avLst/>
+          </a:prstGeom>
+          <a:noFill/>
+          <a:ln/>
+        </p:spPr>
+        <p:txBody>
+          <a:bodyPr wrap="square" lIns="0" tIns="0" rIns="0" bIns="0" rtlCol="0" anchor="ctr"/>
+          <a:lstStyle/>
+          <a:p>
+            <a:pPr indent="0" marL="0">
+              <a:buNone/>
+            </a:pPr>
+            <a:r>
+              <a:rPr lang="en-US" sz="950" i="1" dirty="0">
+                <a:solidFill>
+                  <a:srgbClr val="64748B"/>
+                </a:solidFill>
+                <a:latin typeface="Calibri" pitchFamily="34" charset="0"/>
+                <a:ea typeface="Calibri" pitchFamily="34" charset="-122"/>
+                <a:cs typeface="Calibri" pitchFamily="34" charset="-120"/>
+              </a:rPr>
+              <a:t>Scenario: Patient at Node 1 (JSSATE)  |  Emergency: TRAUMA  |  Needs ICU</a:t>
+            </a:r>
+            <a:endParaRPr lang="en-US" sz="950" dirty="0"/>
+          </a:p>
+        </p:txBody>
+      </p:sp>
+      <p:sp>
+        <p:nvSpPr>
+          <p:cNvPr id="18" name="Text 16"/>
+          <p:cNvSpPr/>
+          <p:nvPr/>
+        </p:nvSpPr>
+        <p:spPr>
+          <a:xfrm>
+            <a:off x="1078992" y="2944368"/>
+            <a:ext cx="5349240" cy="502920"/>
+          </a:xfrm>
+          <a:prstGeom prst="rect">
+            <a:avLst/>
+          </a:prstGeom>
+          <a:noFill/>
+          <a:ln/>
+        </p:spPr>
+        <p:txBody>
+          <a:bodyPr wrap="square" lIns="0" tIns="0" rIns="0" bIns="0" rtlCol="0" anchor="ctr"/>
+          <a:lstStyle/>
+          <a:p>
+            <a:pPr indent="0" marL="0">
+              <a:buNone/>
+            </a:pPr>
+            <a:r>
+              <a:rPr lang="en-US" sz="1000" dirty="0">
+                <a:solidFill>
+                  <a:srgbClr val="1E293B"/>
+                </a:solidFill>
+                <a:latin typeface="Calibri" pitchFamily="34" charset="0"/>
+                <a:ea typeface="Calibri" pitchFamily="34" charset="-122"/>
+                <a:cs typeface="Calibri" pitchFamily="34" charset="-120"/>
+              </a:rPr>
+              <a:t>Result: BGS (1.2 km) handles CARDIAC not TRAUMA — filtered at Stage 1. RRMCH (Node 8, 7.2 km) handles TRAUMA with ICU available — selected as PRIMARY.</a:t>
+            </a:r>
+            <a:endParaRPr lang="en-US" sz="1000" dirty="0"/>
+          </a:p>
+        </p:txBody>
+      </p:sp>
+      <p:sp>
+        <p:nvSpPr>
+          <p:cNvPr id="19" name="Shape 17"/>
+          <p:cNvSpPr/>
+          <p:nvPr/>
+        </p:nvSpPr>
+        <p:spPr>
+          <a:xfrm>
+            <a:off x="6565392" y="2907792"/>
+            <a:ext cx="2121408" cy="475488"/>
+          </a:xfrm>
+          <a:prstGeom prst="roundRect">
+            <a:avLst>
+              <a:gd name="adj" fmla="val 9615"/>
+            </a:avLst>
+          </a:prstGeom>
+          <a:solidFill>
+            <a:srgbClr val="F59E0B"/>
+          </a:solidFill>
+          <a:ln/>
+        </p:spPr>
+      </p:sp>
+      <p:sp>
+        <p:nvSpPr>
+          <p:cNvPr id="20" name="Text 18"/>
+          <p:cNvSpPr/>
+          <p:nvPr/>
+        </p:nvSpPr>
+        <p:spPr>
+          <a:xfrm>
+            <a:off x="6565392" y="2907792"/>
+            <a:ext cx="2121408" cy="475488"/>
+          </a:xfrm>
+          <a:prstGeom prst="rect">
+            <a:avLst/>
+          </a:prstGeom>
+          <a:noFill/>
+          <a:ln/>
+        </p:spPr>
+        <p:txBody>
+          <a:bodyPr wrap="square" lIns="38100" tIns="38100" rIns="38100" bIns="38100" rtlCol="0" anchor="ctr"/>
+          <a:lstStyle/>
+          <a:p>
+            <a:pPr algn="ctr" indent="0" marL="0">
+              <a:buNone/>
+            </a:pPr>
+            <a:r>
+              <a:rPr lang="en-US" sz="850" dirty="0">
+                <a:solidFill>
+                  <a:srgbClr val="FFFFFF"/>
+                </a:solidFill>
+                <a:latin typeface="Calibri" pitchFamily="34" charset="0"/>
+                <a:ea typeface="Calibri" pitchFamily="34" charset="-122"/>
+                <a:cs typeface="Calibri" pitchFamily="34" charset="-120"/>
+              </a:rPr>
+              <a:t>Nearest ≠ Best. Type + ICU filter is the key differentiator.</a:t>
+            </a:r>
+            <a:endParaRPr lang="en-US" sz="850" dirty="0"/>
+          </a:p>
+        </p:txBody>
+      </p:sp>
+      <p:sp>
+        <p:nvSpPr>
+          <p:cNvPr id="21" name="Shape 19"/>
+          <p:cNvSpPr/>
+          <p:nvPr/>
+        </p:nvSpPr>
+        <p:spPr>
+          <a:xfrm>
+            <a:off x="320040" y="3666744"/>
+            <a:ext cx="8503920" cy="1115568"/>
+          </a:xfrm>
+          <a:prstGeom prst="rect">
+            <a:avLst/>
+          </a:prstGeom>
+          <a:solidFill>
+            <a:srgbClr val="FFFFFF"/>
+          </a:solidFill>
+          <a:ln/>
+          <a:effectLst>
+            <a:outerShdw sx="100000" sy="100000" kx="0" ky="0" algn="bl" rotWithShape="0" blurRad="101600" dist="38100" dir="8100000">
+              <a:srgbClr val="000000">
+                <a:alpha val="12000"/>
+              </a:srgbClr>
+            </a:outerShdw>
+          </a:effectLst>
+        </p:spPr>
+      </p:sp>
+      <p:sp>
+        <p:nvSpPr>
+          <p:cNvPr id="22" name="Shape 20"/>
+          <p:cNvSpPr/>
+          <p:nvPr/>
+        </p:nvSpPr>
+        <p:spPr>
+          <a:xfrm>
+            <a:off x="320040" y="3666744"/>
+            <a:ext cx="658368" cy="1115568"/>
+          </a:xfrm>
+          <a:prstGeom prst="rect">
+            <a:avLst/>
+          </a:prstGeom>
+          <a:solidFill>
+            <a:srgbClr val="00B4D8"/>
+          </a:solidFill>
+          <a:ln/>
+        </p:spPr>
+      </p:sp>
+      <p:sp>
+        <p:nvSpPr>
+          <p:cNvPr id="23" name="Text 21"/>
+          <p:cNvSpPr/>
+          <p:nvPr/>
+        </p:nvSpPr>
+        <p:spPr>
+          <a:xfrm>
+            <a:off x="320040" y="3666744"/>
+            <a:ext cx="658368" cy="1115568"/>
+          </a:xfrm>
+          <a:prstGeom prst="rect">
+            <a:avLst/>
+          </a:prstGeom>
+          <a:noFill/>
+          <a:ln/>
+        </p:spPr>
+        <p:txBody>
+          <a:bodyPr wrap="square" lIns="0" tIns="0" rIns="0" bIns="0" rtlCol="0" anchor="ctr"/>
+          <a:lstStyle/>
+          <a:p>
+            <a:pPr algn="ctr" indent="0" marL="0">
+              <a:buNone/>
+            </a:pPr>
+            <a:r>
+              <a:rPr lang="en-US" sz="2800" b="1" dirty="0">
+                <a:solidFill>
+                  <a:srgbClr val="FFFFFF"/>
+                </a:solidFill>
+                <a:latin typeface="Calibri" pitchFamily="34" charset="0"/>
+                <a:ea typeface="Calibri" pitchFamily="34" charset="-122"/>
+                <a:cs typeface="Calibri" pitchFamily="34" charset="-120"/>
+              </a:rPr>
+              <a:t>03</a:t>
+            </a:r>
+            <a:endParaRPr lang="en-US" sz="2800" dirty="0"/>
+          </a:p>
+        </p:txBody>
+      </p:sp>
+      <p:sp>
+        <p:nvSpPr>
+          <p:cNvPr id="24" name="Text 22"/>
+          <p:cNvSpPr/>
+          <p:nvPr/>
+        </p:nvSpPr>
+        <p:spPr>
+          <a:xfrm>
+            <a:off x="1078992" y="3730752"/>
+            <a:ext cx="7205472" cy="274320"/>
+          </a:xfrm>
+          <a:prstGeom prst="rect">
+            <a:avLst/>
+          </a:prstGeom>
+          <a:noFill/>
+          <a:ln/>
+        </p:spPr>
+        <p:txBody>
+          <a:bodyPr wrap="square" lIns="0" tIns="0" rIns="0" bIns="0" rtlCol="0" anchor="ctr"/>
+          <a:lstStyle/>
+          <a:p>
+            <a:pPr indent="0" marL="0">
+              <a:buNone/>
+            </a:pPr>
+            <a:r>
+              <a:rPr lang="en-US" sz="1300" b="1" dirty="0">
+                <a:solidFill>
+                  <a:srgbClr val="1E293B"/>
+                </a:solidFill>
+                <a:latin typeface="Calibri" pitchFamily="34" charset="0"/>
+                <a:ea typeface="Calibri" pitchFamily="34" charset="-122"/>
+                <a:cs typeface="Calibri" pitchFamily="34" charset="-120"/>
+              </a:rPr>
+              <a:t>Multiple Valid Hospitals — Dijkstra Decides the Winner</a:t>
+            </a:r>
+            <a:endParaRPr lang="en-US" sz="1300" dirty="0"/>
+          </a:p>
+        </p:txBody>
+      </p:sp>
+      <p:sp>
+        <p:nvSpPr>
+          <p:cNvPr id="25" name="Text 23"/>
+          <p:cNvSpPr/>
+          <p:nvPr/>
+        </p:nvSpPr>
+        <p:spPr>
+          <a:xfrm>
+            <a:off x="1078992" y="4005072"/>
+            <a:ext cx="7205472" cy="201168"/>
+          </a:xfrm>
+          <a:prstGeom prst="rect">
+            <a:avLst/>
+          </a:prstGeom>
+          <a:noFill/>
+          <a:ln/>
+        </p:spPr>
+        <p:txBody>
+          <a:bodyPr wrap="square" lIns="0" tIns="0" rIns="0" bIns="0" rtlCol="0" anchor="ctr"/>
+          <a:lstStyle/>
+          <a:p>
+            <a:pPr indent="0" marL="0">
+              <a:buNone/>
+            </a:pPr>
+            <a:r>
+              <a:rPr lang="en-US" sz="950" i="1" dirty="0">
+                <a:solidFill>
+                  <a:srgbClr val="64748B"/>
+                </a:solidFill>
+                <a:latin typeface="Calibri" pitchFamily="34" charset="0"/>
+                <a:ea typeface="Calibri" pitchFamily="34" charset="-122"/>
+                <a:cs typeface="Calibri" pitchFamily="34" charset="-120"/>
+              </a:rPr>
+              <a:t>Scenario: Patient at Node 10 (BSK Temple)  |  Emergency: CARDIAC  |  Needs ICU</a:t>
+            </a:r>
+            <a:endParaRPr lang="en-US" sz="950" dirty="0"/>
+          </a:p>
+        </p:txBody>
+      </p:sp>
+      <p:sp>
+        <p:nvSpPr>
+          <p:cNvPr id="26" name="Text 24"/>
+          <p:cNvSpPr/>
+          <p:nvPr/>
+        </p:nvSpPr>
+        <p:spPr>
+          <a:xfrm>
+            <a:off x="1078992" y="4206240"/>
+            <a:ext cx="5349240" cy="502920"/>
+          </a:xfrm>
+          <a:prstGeom prst="rect">
+            <a:avLst/>
+          </a:prstGeom>
+          <a:noFill/>
+          <a:ln/>
+        </p:spPr>
+        <p:txBody>
+          <a:bodyPr wrap="square" lIns="0" tIns="0" rIns="0" bIns="0" rtlCol="0" anchor="ctr"/>
+          <a:lstStyle/>
+          <a:p>
+            <a:pPr indent="0" marL="0">
+              <a:buNone/>
+            </a:pPr>
+            <a:r>
+              <a:rPr lang="en-US" sz="1000" dirty="0">
+                <a:solidFill>
+                  <a:srgbClr val="1E293B"/>
+                </a:solidFill>
+                <a:latin typeface="Calibri" pitchFamily="34" charset="0"/>
+                <a:ea typeface="Calibri" pitchFamily="34" charset="-122"/>
+                <a:cs typeface="Calibri" pitchFamily="34" charset="-120"/>
+              </a:rPr>
+              <a:t>Result: BGS, Apollo &amp; Fortis all handle CARDIAC with ICU. Dijkstra computes road distances — Apollo (Node 11) wins at ~5.5 km vs BGS at 9+ km.</a:t>
+            </a:r>
+            <a:endParaRPr lang="en-US" sz="1000" dirty="0"/>
+          </a:p>
+        </p:txBody>
+      </p:sp>
+      <p:sp>
+        <p:nvSpPr>
+          <p:cNvPr id="27" name="Shape 25"/>
+          <p:cNvSpPr/>
+          <p:nvPr/>
+        </p:nvSpPr>
+        <p:spPr>
+          <a:xfrm>
+            <a:off x="6565392" y="4169664"/>
+            <a:ext cx="2121408" cy="475488"/>
+          </a:xfrm>
+          <a:prstGeom prst="roundRect">
+            <a:avLst>
+              <a:gd name="adj" fmla="val 9615"/>
+            </a:avLst>
+          </a:prstGeom>
+          <a:solidFill>
+            <a:srgbClr val="00B4D8"/>
+          </a:solidFill>
+          <a:ln/>
+        </p:spPr>
+      </p:sp>
+      <p:sp>
+        <p:nvSpPr>
+          <p:cNvPr id="28" name="Text 26"/>
+          <p:cNvSpPr/>
+          <p:nvPr/>
+        </p:nvSpPr>
+        <p:spPr>
+          <a:xfrm>
+            <a:off x="6565392" y="4169664"/>
+            <a:ext cx="2121408" cy="475488"/>
+          </a:xfrm>
+          <a:prstGeom prst="rect">
+            <a:avLst/>
+          </a:prstGeom>
+          <a:noFill/>
+          <a:ln/>
+        </p:spPr>
+        <p:txBody>
+          <a:bodyPr wrap="square" lIns="38100" tIns="38100" rIns="38100" bIns="38100" rtlCol="0" anchor="ctr"/>
+          <a:lstStyle/>
+          <a:p>
+            <a:pPr algn="ctr" indent="0" marL="0">
+              <a:buNone/>
+            </a:pPr>
+            <a:r>
+              <a:rPr lang="en-US" sz="850" dirty="0">
+                <a:solidFill>
+                  <a:srgbClr val="FFFFFF"/>
+                </a:solidFill>
+                <a:latin typeface="Calibri" pitchFamily="34" charset="0"/>
+                <a:ea typeface="Calibri" pitchFamily="34" charset="-122"/>
+                <a:cs typeface="Calibri" pitchFamily="34" charset="-120"/>
+              </a:rPr>
+              <a:t>Best viva case — Dijkstra's role is crystal clear here.</a:t>
+            </a:r>
+            <a:endParaRPr lang="en-US" sz="850" dirty="0"/>
+          </a:p>
+        </p:txBody>
+      </p:sp>
+    </p:spTree>
+  </p:cSld>
+  <p:clrMapOvr>
+    <a:masterClrMapping/>
+  </p:clrMapOvr>
+</p:sld>
+</file>
+
+<file path=ppt/slides/slide11.xml><?xml version="1.0" encoding="utf-8"?>
+<p:sld xmlns:a="http://schemas.openxmlformats.org/drawingml/2006/main" xmlns:r="http://schemas.openxmlformats.org/officeDocument/2006/relationships" xmlns:p="http://schemas.openxmlformats.org/presentationml/2006/main">
+  <p:cSld name="Slide 11">
+    <p:bg>
+      <p:bgPr>
+        <a:solidFill>
           <a:srgbClr val="0B1D3A"/>
         </a:solidFill>
       </p:bgPr>
@@ -2274,13 +3266,6 @@
             <a:srgbClr val="112B52"/>
           </a:solidFill>
           <a:ln/>
-          <a:effectLst>
-            <a:outerShdw sx="100000" sy="100000" kx="0" ky="0" algn="bl" rotWithShape="0" blurRad="101600" dist="38100" dir="8100000">
-              <a:srgbClr val="000000">
-                <a:alpha val="12000"/>
-              </a:srgbClr>
-            </a:outerShdw>
-          </a:effectLst>
         </p:spPr>
       </p:sp>
       <p:sp>
@@ -2328,7 +3313,7 @@
               <a:buNone/>
             </a:pPr>
             <a:r>
-              <a:rPr lang="en-US" sz="1350" i="1" dirty="0">
+              <a:rPr lang="en-US" sz="1400" i="1" dirty="0">
                 <a:solidFill>
                   <a:srgbClr val="E0F0FF"/>
                 </a:solidFill>
@@ -2338,7 +3323,7 @@
               </a:rPr>
               <a:t>"This project uses DBMS to store hospitals and roads, Advanced Java to build the application, Graph Theory to model and solve routing, and Algorithm Design to compare and justify the recommendation strategy."</a:t>
             </a:r>
-            <a:endParaRPr lang="en-US" sz="1350" dirty="0"/>
+            <a:endParaRPr lang="en-US" sz="1400" dirty="0"/>
           </a:p>
         </p:txBody>
       </p:sp>
@@ -2360,13 +3345,6 @@
             <a:srgbClr val="F59E0B"/>
           </a:solidFill>
           <a:ln/>
-          <a:effectLst>
-            <a:outerShdw sx="100000" sy="100000" kx="0" ky="0" algn="bl" rotWithShape="0" blurRad="101600" dist="38100" dir="8100000">
-              <a:srgbClr val="000000">
-                <a:alpha val="12000"/>
-              </a:srgbClr>
-            </a:outerShdw>
-          </a:effectLst>
         </p:spPr>
       </p:sp>
       <p:sp>
@@ -2465,13 +3443,6 @@
             <a:srgbClr val="10B981"/>
           </a:solidFill>
           <a:ln/>
-          <a:effectLst>
-            <a:outerShdw sx="100000" sy="100000" kx="0" ky="0" algn="bl" rotWithShape="0" blurRad="101600" dist="38100" dir="8100000">
-              <a:srgbClr val="000000">
-                <a:alpha val="12000"/>
-              </a:srgbClr>
-            </a:outerShdw>
-          </a:effectLst>
         </p:spPr>
       </p:sp>
       <p:sp>
@@ -2570,13 +3541,6 @@
             <a:srgbClr val="8B5CF6"/>
           </a:solidFill>
           <a:ln/>
-          <a:effectLst>
-            <a:outerShdw sx="100000" sy="100000" kx="0" ky="0" algn="bl" rotWithShape="0" blurRad="101600" dist="38100" dir="8100000">
-              <a:srgbClr val="000000">
-                <a:alpha val="12000"/>
-              </a:srgbClr>
-            </a:outerShdw>
-          </a:effectLst>
         </p:spPr>
       </p:sp>
       <p:sp>
@@ -2675,13 +3639,6 @@
             <a:srgbClr val="00B4D8"/>
           </a:solidFill>
           <a:ln/>
-          <a:effectLst>
-            <a:outerShdw sx="100000" sy="100000" kx="0" ky="0" algn="bl" rotWithShape="0" blurRad="101600" dist="38100" dir="8100000">
-              <a:srgbClr val="000000">
-                <a:alpha val="12000"/>
-              </a:srgbClr>
-            </a:outerShdw>
-          </a:effectLst>
         </p:spPr>
       </p:sp>
       <p:sp>
@@ -2787,7 +3744,7 @@
               <a:buNone/>
             </a:pPr>
             <a:r>
-              <a:rPr lang="en-US" sz="1000" i="1" dirty="0">
+              <a:rPr lang="en-US" sz="1100" i="1" dirty="0">
                 <a:solidFill>
                   <a:srgbClr val="64748B"/>
                 </a:solidFill>
@@ -2797,7 +3754,7 @@
               </a:rPr>
               <a:t>Smart Ambulance Routing &amp; Hospital Allocation System  ·  South Bangalore City Map  ·  13 Nodes  ·  6 Hospitals</a:t>
             </a:r>
-            <a:endParaRPr lang="en-US" sz="1000" dirty="0"/>
+            <a:endParaRPr lang="en-US" sz="1100" dirty="0"/>
           </a:p>
         </p:txBody>
       </p:sp>
@@ -10823,7 +11780,7 @@
     <p:bg>
       <p:bgPr>
         <a:solidFill>
-          <a:srgbClr val="F8FAFF"/>
+          <a:srgbClr val="0B1D3A"/>
         </a:solidFill>
       </p:bgPr>
     </p:bg>
@@ -10856,7 +11813,7 @@
             <a:avLst/>
           </a:prstGeom>
           <a:solidFill>
-            <a:srgbClr val="0B1D3A"/>
+            <a:srgbClr val="112B52"/>
           </a:solidFill>
           <a:ln/>
         </p:spPr>
@@ -10894,7 +11851,7 @@
                 <a:ea typeface="Calibri" pitchFamily="34" charset="-122"/>
                 <a:cs typeface="Calibri" pitchFamily="34" charset="-120"/>
               </a:rPr>
-              <a:t>3 Demo Cases to Explain During Presentation</a:t>
+              <a:t>How All 4 Subjects Work Together</a:t>
             </a:r>
             <a:endParaRPr lang="en-US" sz="2400" dirty="0"/>
           </a:p>
@@ -10908,23 +11865,16 @@
         </p:nvSpPr>
         <p:spPr>
           <a:xfrm>
-            <a:off x="320040" y="1143000"/>
-            <a:ext cx="8503920" cy="1115568"/>
-          </a:xfrm>
-          <a:prstGeom prst="rect">
-            <a:avLst/>
-          </a:prstGeom>
-          <a:solidFill>
-            <a:srgbClr val="FFFFFF"/>
-          </a:solidFill>
-          <a:ln/>
-          <a:effectLst>
-            <a:outerShdw sx="100000" sy="100000" kx="0" ky="0" algn="bl" rotWithShape="0" blurRad="101600" dist="38100" dir="8100000">
-              <a:srgbClr val="000000">
-                <a:alpha val="12000"/>
-              </a:srgbClr>
-            </a:outerShdw>
-          </a:effectLst>
+            <a:off x="274320" y="1143000"/>
+            <a:ext cx="2011680" cy="3566160"/>
+          </a:xfrm>
+          <a:prstGeom prst="rect">
+            <a:avLst/>
+          </a:prstGeom>
+          <a:solidFill>
+            <a:srgbClr val="112B52"/>
+          </a:solidFill>
+          <a:ln/>
         </p:spPr>
       </p:sp>
       <p:sp>
@@ -10935,8 +11885,665 @@
         </p:nvSpPr>
         <p:spPr>
           <a:xfrm>
-            <a:off x="320040" y="1143000"/>
-            <a:ext cx="658368" cy="1115568"/>
+            <a:off x="274320" y="1143000"/>
+            <a:ext cx="2011680" cy="548640"/>
+          </a:xfrm>
+          <a:prstGeom prst="rect">
+            <a:avLst/>
+          </a:prstGeom>
+          <a:solidFill>
+            <a:srgbClr val="F59E0B"/>
+          </a:solidFill>
+          <a:ln/>
+        </p:spPr>
+      </p:sp>
+      <p:sp>
+        <p:nvSpPr>
+          <p:cNvPr id="6" name="Text 4"/>
+          <p:cNvSpPr/>
+          <p:nvPr/>
+        </p:nvSpPr>
+        <p:spPr>
+          <a:xfrm>
+            <a:off x="274320" y="1161288"/>
+            <a:ext cx="2011680" cy="274320"/>
+          </a:xfrm>
+          <a:prstGeom prst="rect">
+            <a:avLst/>
+          </a:prstGeom>
+          <a:noFill/>
+          <a:ln/>
+        </p:spPr>
+        <p:txBody>
+          <a:bodyPr wrap="square" lIns="0" tIns="0" rIns="0" bIns="0" rtlCol="0" anchor="ctr"/>
+          <a:lstStyle/>
+          <a:p>
+            <a:pPr algn="ctr" indent="0" marL="0">
+              <a:buNone/>
+            </a:pPr>
+            <a:r>
+              <a:rPr lang="en-US" sz="1300" b="1" dirty="0">
+                <a:solidFill>
+                  <a:srgbClr val="FFFFFF"/>
+                </a:solidFill>
+                <a:latin typeface="Calibri" pitchFamily="34" charset="0"/>
+                <a:ea typeface="Calibri" pitchFamily="34" charset="-122"/>
+                <a:cs typeface="Calibri" pitchFamily="34" charset="-120"/>
+              </a:rPr>
+              <a:t>BCS401</a:t>
+            </a:r>
+            <a:endParaRPr lang="en-US" sz="1300" dirty="0"/>
+          </a:p>
+        </p:txBody>
+      </p:sp>
+      <p:sp>
+        <p:nvSpPr>
+          <p:cNvPr id="7" name="Text 5"/>
+          <p:cNvSpPr/>
+          <p:nvPr/>
+        </p:nvSpPr>
+        <p:spPr>
+          <a:xfrm>
+            <a:off x="274320" y="1417320"/>
+            <a:ext cx="2011680" cy="256032"/>
+          </a:xfrm>
+          <a:prstGeom prst="rect">
+            <a:avLst/>
+          </a:prstGeom>
+          <a:noFill/>
+          <a:ln/>
+        </p:spPr>
+        <p:txBody>
+          <a:bodyPr wrap="square" lIns="0" tIns="0" rIns="0" bIns="0" rtlCol="0" anchor="ctr"/>
+          <a:lstStyle/>
+          <a:p>
+            <a:pPr algn="ctr" indent="0" marL="0">
+              <a:buNone/>
+            </a:pPr>
+            <a:r>
+              <a:rPr lang="en-US" sz="1000" dirty="0">
+                <a:solidFill>
+                  <a:srgbClr val="FFFFFF"/>
+                </a:solidFill>
+                <a:latin typeface="Calibri" pitchFamily="34" charset="0"/>
+                <a:ea typeface="Calibri" pitchFamily="34" charset="-122"/>
+                <a:cs typeface="Calibri" pitchFamily="34" charset="-120"/>
+              </a:rPr>
+              <a:t>Algorithm Design</a:t>
+            </a:r>
+            <a:endParaRPr lang="en-US" sz="1000" dirty="0"/>
+          </a:p>
+        </p:txBody>
+      </p:sp>
+      <p:sp>
+        <p:nvSpPr>
+          <p:cNvPr id="8" name="Text 6"/>
+          <p:cNvSpPr/>
+          <p:nvPr/>
+        </p:nvSpPr>
+        <p:spPr>
+          <a:xfrm>
+            <a:off x="960120" y="1874520"/>
+            <a:ext cx="594360" cy="594360"/>
+          </a:xfrm>
+          <a:prstGeom prst="rect">
+            <a:avLst/>
+          </a:prstGeom>
+          <a:noFill/>
+          <a:ln/>
+        </p:spPr>
+        <p:txBody>
+          <a:bodyPr wrap="square" lIns="0" tIns="0" rIns="0" bIns="0" rtlCol="0" anchor="ctr"/>
+          <a:lstStyle/>
+          <a:p>
+            <a:pPr algn="ctr" indent="0" marL="0">
+              <a:buNone/>
+            </a:pPr>
+            <a:r>
+              <a:rPr lang="en-US" sz="2800" dirty="0">
+                <a:solidFill>
+                  <a:srgbClr val="000000"/>
+                </a:solidFill>
+                <a:latin typeface="Segoe UI Emoji" pitchFamily="34" charset="0"/>
+                <a:ea typeface="Segoe UI Emoji" pitchFamily="34" charset="-122"/>
+                <a:cs typeface="Segoe UI Emoji" pitchFamily="34" charset="-120"/>
+              </a:rPr>
+              <a:t>📊</a:t>
+            </a:r>
+            <a:endParaRPr lang="en-US" sz="2800" dirty="0"/>
+          </a:p>
+        </p:txBody>
+      </p:sp>
+      <p:sp>
+        <p:nvSpPr>
+          <p:cNvPr id="9" name="Text 7"/>
+          <p:cNvSpPr/>
+          <p:nvPr/>
+        </p:nvSpPr>
+        <p:spPr>
+          <a:xfrm>
+            <a:off x="384048" y="2606040"/>
+            <a:ext cx="1792224" cy="2011680"/>
+          </a:xfrm>
+          <a:prstGeom prst="rect">
+            <a:avLst/>
+          </a:prstGeom>
+          <a:noFill/>
+          <a:ln/>
+        </p:spPr>
+        <p:txBody>
+          <a:bodyPr wrap="square" lIns="0" tIns="0" rIns="0" bIns="0" rtlCol="0" anchor="ctr"/>
+          <a:lstStyle/>
+          <a:p>
+            <a:pPr algn="ctr" indent="0" marL="0">
+              <a:buNone/>
+            </a:pPr>
+            <a:r>
+              <a:rPr lang="en-US" sz="1050" dirty="0">
+                <a:solidFill>
+                  <a:srgbClr val="E0F0FF"/>
+                </a:solidFill>
+                <a:latin typeface="Calibri" pitchFamily="34" charset="0"/>
+                <a:ea typeface="Calibri" pitchFamily="34" charset="-122"/>
+                <a:cs typeface="Calibri" pitchFamily="34" charset="-120"/>
+              </a:rPr>
+              <a:t>Defines the PROBLEM and justifies WHY Dijkstra is used over brute-force</a:t>
+            </a:r>
+            <a:endParaRPr lang="en-US" sz="1050" dirty="0"/>
+          </a:p>
+        </p:txBody>
+      </p:sp>
+      <p:sp>
+        <p:nvSpPr>
+          <p:cNvPr id="10" name="Shape 8"/>
+          <p:cNvSpPr/>
+          <p:nvPr/>
+        </p:nvSpPr>
+        <p:spPr>
+          <a:xfrm>
+            <a:off x="2286000" y="2926080"/>
+            <a:ext cx="201168" cy="0"/>
+          </a:xfrm>
+          <a:prstGeom prst="line">
+            <a:avLst/>
+          </a:prstGeom>
+          <a:noFill/>
+          <a:ln w="25400">
+            <a:solidFill>
+              <a:srgbClr val="00B4D8"/>
+            </a:solidFill>
+            <a:prstDash val="solid"/>
+          </a:ln>
+        </p:spPr>
+      </p:sp>
+      <p:sp>
+        <p:nvSpPr>
+          <p:cNvPr id="11" name="Shape 9"/>
+          <p:cNvSpPr/>
+          <p:nvPr/>
+        </p:nvSpPr>
+        <p:spPr>
+          <a:xfrm>
+            <a:off x="2487168" y="1143000"/>
+            <a:ext cx="2011680" cy="3566160"/>
+          </a:xfrm>
+          <a:prstGeom prst="rect">
+            <a:avLst/>
+          </a:prstGeom>
+          <a:solidFill>
+            <a:srgbClr val="112B52"/>
+          </a:solidFill>
+          <a:ln/>
+        </p:spPr>
+      </p:sp>
+      <p:sp>
+        <p:nvSpPr>
+          <p:cNvPr id="12" name="Shape 10"/>
+          <p:cNvSpPr/>
+          <p:nvPr/>
+        </p:nvSpPr>
+        <p:spPr>
+          <a:xfrm>
+            <a:off x="2487168" y="1143000"/>
+            <a:ext cx="2011680" cy="548640"/>
+          </a:xfrm>
+          <a:prstGeom prst="rect">
+            <a:avLst/>
+          </a:prstGeom>
+          <a:solidFill>
+            <a:srgbClr val="8B5CF6"/>
+          </a:solidFill>
+          <a:ln/>
+        </p:spPr>
+      </p:sp>
+      <p:sp>
+        <p:nvSpPr>
+          <p:cNvPr id="13" name="Text 11"/>
+          <p:cNvSpPr/>
+          <p:nvPr/>
+        </p:nvSpPr>
+        <p:spPr>
+          <a:xfrm>
+            <a:off x="2487168" y="1161288"/>
+            <a:ext cx="2011680" cy="274320"/>
+          </a:xfrm>
+          <a:prstGeom prst="rect">
+            <a:avLst/>
+          </a:prstGeom>
+          <a:noFill/>
+          <a:ln/>
+        </p:spPr>
+        <p:txBody>
+          <a:bodyPr wrap="square" lIns="0" tIns="0" rIns="0" bIns="0" rtlCol="0" anchor="ctr"/>
+          <a:lstStyle/>
+          <a:p>
+            <a:pPr algn="ctr" indent="0" marL="0">
+              <a:buNone/>
+            </a:pPr>
+            <a:r>
+              <a:rPr lang="en-US" sz="1300" b="1" dirty="0">
+                <a:solidFill>
+                  <a:srgbClr val="FFFFFF"/>
+                </a:solidFill>
+                <a:latin typeface="Calibri" pitchFamily="34" charset="0"/>
+                <a:ea typeface="Calibri" pitchFamily="34" charset="-122"/>
+                <a:cs typeface="Calibri" pitchFamily="34" charset="-120"/>
+              </a:rPr>
+              <a:t>BCS403</a:t>
+            </a:r>
+            <a:endParaRPr lang="en-US" sz="1300" dirty="0"/>
+          </a:p>
+        </p:txBody>
+      </p:sp>
+      <p:sp>
+        <p:nvSpPr>
+          <p:cNvPr id="14" name="Text 12"/>
+          <p:cNvSpPr/>
+          <p:nvPr/>
+        </p:nvSpPr>
+        <p:spPr>
+          <a:xfrm>
+            <a:off x="2487168" y="1417320"/>
+            <a:ext cx="2011680" cy="256032"/>
+          </a:xfrm>
+          <a:prstGeom prst="rect">
+            <a:avLst/>
+          </a:prstGeom>
+          <a:noFill/>
+          <a:ln/>
+        </p:spPr>
+        <p:txBody>
+          <a:bodyPr wrap="square" lIns="0" tIns="0" rIns="0" bIns="0" rtlCol="0" anchor="ctr"/>
+          <a:lstStyle/>
+          <a:p>
+            <a:pPr algn="ctr" indent="0" marL="0">
+              <a:buNone/>
+            </a:pPr>
+            <a:r>
+              <a:rPr lang="en-US" sz="1000" dirty="0">
+                <a:solidFill>
+                  <a:srgbClr val="FFFFFF"/>
+                </a:solidFill>
+                <a:latin typeface="Calibri" pitchFamily="34" charset="0"/>
+                <a:ea typeface="Calibri" pitchFamily="34" charset="-122"/>
+                <a:cs typeface="Calibri" pitchFamily="34" charset="-120"/>
+              </a:rPr>
+              <a:t>DBMS</a:t>
+            </a:r>
+            <a:endParaRPr lang="en-US" sz="1000" dirty="0"/>
+          </a:p>
+        </p:txBody>
+      </p:sp>
+      <p:sp>
+        <p:nvSpPr>
+          <p:cNvPr id="15" name="Text 13"/>
+          <p:cNvSpPr/>
+          <p:nvPr/>
+        </p:nvSpPr>
+        <p:spPr>
+          <a:xfrm>
+            <a:off x="3172968" y="1874520"/>
+            <a:ext cx="594360" cy="594360"/>
+          </a:xfrm>
+          <a:prstGeom prst="rect">
+            <a:avLst/>
+          </a:prstGeom>
+          <a:noFill/>
+          <a:ln/>
+        </p:spPr>
+        <p:txBody>
+          <a:bodyPr wrap="square" lIns="0" tIns="0" rIns="0" bIns="0" rtlCol="0" anchor="ctr"/>
+          <a:lstStyle/>
+          <a:p>
+            <a:pPr algn="ctr" indent="0" marL="0">
+              <a:buNone/>
+            </a:pPr>
+            <a:r>
+              <a:rPr lang="en-US" sz="2800" dirty="0">
+                <a:solidFill>
+                  <a:srgbClr val="000000"/>
+                </a:solidFill>
+                <a:latin typeface="Segoe UI Emoji" pitchFamily="34" charset="0"/>
+                <a:ea typeface="Segoe UI Emoji" pitchFamily="34" charset="-122"/>
+                <a:cs typeface="Segoe UI Emoji" pitchFamily="34" charset="-120"/>
+              </a:rPr>
+              <a:t>🗄</a:t>
+            </a:r>
+            <a:endParaRPr lang="en-US" sz="2800" dirty="0"/>
+          </a:p>
+        </p:txBody>
+      </p:sp>
+      <p:sp>
+        <p:nvSpPr>
+          <p:cNvPr id="16" name="Text 14"/>
+          <p:cNvSpPr/>
+          <p:nvPr/>
+        </p:nvSpPr>
+        <p:spPr>
+          <a:xfrm>
+            <a:off x="2596896" y="2606040"/>
+            <a:ext cx="1792224" cy="2011680"/>
+          </a:xfrm>
+          <a:prstGeom prst="rect">
+            <a:avLst/>
+          </a:prstGeom>
+          <a:noFill/>
+          <a:ln/>
+        </p:spPr>
+        <p:txBody>
+          <a:bodyPr wrap="square" lIns="0" tIns="0" rIns="0" bIns="0" rtlCol="0" anchor="ctr"/>
+          <a:lstStyle/>
+          <a:p>
+            <a:pPr algn="ctr" indent="0" marL="0">
+              <a:buNone/>
+            </a:pPr>
+            <a:r>
+              <a:rPr lang="en-US" sz="1050" dirty="0">
+                <a:solidFill>
+                  <a:srgbClr val="E0F0FF"/>
+                </a:solidFill>
+                <a:latin typeface="Calibri" pitchFamily="34" charset="0"/>
+                <a:ea typeface="Calibri" pitchFamily="34" charset="-122"/>
+                <a:cs typeface="Calibri" pitchFamily="34" charset="-120"/>
+              </a:rPr>
+              <a:t>Stores hospital data, roads, patients, and allocation history in a normalized schema</a:t>
+            </a:r>
+            <a:endParaRPr lang="en-US" sz="1050" dirty="0"/>
+          </a:p>
+        </p:txBody>
+      </p:sp>
+      <p:sp>
+        <p:nvSpPr>
+          <p:cNvPr id="17" name="Shape 15"/>
+          <p:cNvSpPr/>
+          <p:nvPr/>
+        </p:nvSpPr>
+        <p:spPr>
+          <a:xfrm>
+            <a:off x="4498848" y="2926080"/>
+            <a:ext cx="201168" cy="0"/>
+          </a:xfrm>
+          <a:prstGeom prst="line">
+            <a:avLst/>
+          </a:prstGeom>
+          <a:noFill/>
+          <a:ln w="25400">
+            <a:solidFill>
+              <a:srgbClr val="00B4D8"/>
+            </a:solidFill>
+            <a:prstDash val="solid"/>
+          </a:ln>
+        </p:spPr>
+      </p:sp>
+      <p:sp>
+        <p:nvSpPr>
+          <p:cNvPr id="18" name="Shape 16"/>
+          <p:cNvSpPr/>
+          <p:nvPr/>
+        </p:nvSpPr>
+        <p:spPr>
+          <a:xfrm>
+            <a:off x="4700016" y="1143000"/>
+            <a:ext cx="2011680" cy="3566160"/>
+          </a:xfrm>
+          <a:prstGeom prst="rect">
+            <a:avLst/>
+          </a:prstGeom>
+          <a:solidFill>
+            <a:srgbClr val="112B52"/>
+          </a:solidFill>
+          <a:ln/>
+        </p:spPr>
+      </p:sp>
+      <p:sp>
+        <p:nvSpPr>
+          <p:cNvPr id="19" name="Shape 17"/>
+          <p:cNvSpPr/>
+          <p:nvPr/>
+        </p:nvSpPr>
+        <p:spPr>
+          <a:xfrm>
+            <a:off x="4700016" y="1143000"/>
+            <a:ext cx="2011680" cy="548640"/>
+          </a:xfrm>
+          <a:prstGeom prst="rect">
+            <a:avLst/>
+          </a:prstGeom>
+          <a:solidFill>
+            <a:srgbClr val="00B4D8"/>
+          </a:solidFill>
+          <a:ln/>
+        </p:spPr>
+      </p:sp>
+      <p:sp>
+        <p:nvSpPr>
+          <p:cNvPr id="20" name="Text 18"/>
+          <p:cNvSpPr/>
+          <p:nvPr/>
+        </p:nvSpPr>
+        <p:spPr>
+          <a:xfrm>
+            <a:off x="4700016" y="1161288"/>
+            <a:ext cx="2011680" cy="274320"/>
+          </a:xfrm>
+          <a:prstGeom prst="rect">
+            <a:avLst/>
+          </a:prstGeom>
+          <a:noFill/>
+          <a:ln/>
+        </p:spPr>
+        <p:txBody>
+          <a:bodyPr wrap="square" lIns="0" tIns="0" rIns="0" bIns="0" rtlCol="0" anchor="ctr"/>
+          <a:lstStyle/>
+          <a:p>
+            <a:pPr algn="ctr" indent="0" marL="0">
+              <a:buNone/>
+            </a:pPr>
+            <a:r>
+              <a:rPr lang="en-US" sz="1300" b="1" dirty="0">
+                <a:solidFill>
+                  <a:srgbClr val="FFFFFF"/>
+                </a:solidFill>
+                <a:latin typeface="Calibri" pitchFamily="34" charset="0"/>
+                <a:ea typeface="Calibri" pitchFamily="34" charset="-122"/>
+                <a:cs typeface="Calibri" pitchFamily="34" charset="-120"/>
+              </a:rPr>
+              <a:t>BCS405B</a:t>
+            </a:r>
+            <a:endParaRPr lang="en-US" sz="1300" dirty="0"/>
+          </a:p>
+        </p:txBody>
+      </p:sp>
+      <p:sp>
+        <p:nvSpPr>
+          <p:cNvPr id="21" name="Text 19"/>
+          <p:cNvSpPr/>
+          <p:nvPr/>
+        </p:nvSpPr>
+        <p:spPr>
+          <a:xfrm>
+            <a:off x="4700016" y="1417320"/>
+            <a:ext cx="2011680" cy="256032"/>
+          </a:xfrm>
+          <a:prstGeom prst="rect">
+            <a:avLst/>
+          </a:prstGeom>
+          <a:noFill/>
+          <a:ln/>
+        </p:spPr>
+        <p:txBody>
+          <a:bodyPr wrap="square" lIns="0" tIns="0" rIns="0" bIns="0" rtlCol="0" anchor="ctr"/>
+          <a:lstStyle/>
+          <a:p>
+            <a:pPr algn="ctr" indent="0" marL="0">
+              <a:buNone/>
+            </a:pPr>
+            <a:r>
+              <a:rPr lang="en-US" sz="1000" dirty="0">
+                <a:solidFill>
+                  <a:srgbClr val="FFFFFF"/>
+                </a:solidFill>
+                <a:latin typeface="Calibri" pitchFamily="34" charset="0"/>
+                <a:ea typeface="Calibri" pitchFamily="34" charset="-122"/>
+                <a:cs typeface="Calibri" pitchFamily="34" charset="-120"/>
+              </a:rPr>
+              <a:t>Graph Theory</a:t>
+            </a:r>
+            <a:endParaRPr lang="en-US" sz="1000" dirty="0"/>
+          </a:p>
+        </p:txBody>
+      </p:sp>
+      <p:sp>
+        <p:nvSpPr>
+          <p:cNvPr id="22" name="Text 20"/>
+          <p:cNvSpPr/>
+          <p:nvPr/>
+        </p:nvSpPr>
+        <p:spPr>
+          <a:xfrm>
+            <a:off x="5385816" y="1874520"/>
+            <a:ext cx="594360" cy="594360"/>
+          </a:xfrm>
+          <a:prstGeom prst="rect">
+            <a:avLst/>
+          </a:prstGeom>
+          <a:noFill/>
+          <a:ln/>
+        </p:spPr>
+        <p:txBody>
+          <a:bodyPr wrap="square" lIns="0" tIns="0" rIns="0" bIns="0" rtlCol="0" anchor="ctr"/>
+          <a:lstStyle/>
+          <a:p>
+            <a:pPr algn="ctr" indent="0" marL="0">
+              <a:buNone/>
+            </a:pPr>
+            <a:r>
+              <a:rPr lang="en-US" sz="2800" dirty="0">
+                <a:solidFill>
+                  <a:srgbClr val="000000"/>
+                </a:solidFill>
+                <a:latin typeface="Segoe UI Emoji" pitchFamily="34" charset="0"/>
+                <a:ea typeface="Segoe UI Emoji" pitchFamily="34" charset="-122"/>
+                <a:cs typeface="Segoe UI Emoji" pitchFamily="34" charset="-120"/>
+              </a:rPr>
+              <a:t>🕸</a:t>
+            </a:r>
+            <a:endParaRPr lang="en-US" sz="2800" dirty="0"/>
+          </a:p>
+        </p:txBody>
+      </p:sp>
+      <p:sp>
+        <p:nvSpPr>
+          <p:cNvPr id="23" name="Text 21"/>
+          <p:cNvSpPr/>
+          <p:nvPr/>
+        </p:nvSpPr>
+        <p:spPr>
+          <a:xfrm>
+            <a:off x="4809744" y="2606040"/>
+            <a:ext cx="1792224" cy="2011680"/>
+          </a:xfrm>
+          <a:prstGeom prst="rect">
+            <a:avLst/>
+          </a:prstGeom>
+          <a:noFill/>
+          <a:ln/>
+        </p:spPr>
+        <p:txBody>
+          <a:bodyPr wrap="square" lIns="0" tIns="0" rIns="0" bIns="0" rtlCol="0" anchor="ctr"/>
+          <a:lstStyle/>
+          <a:p>
+            <a:pPr algn="ctr" indent="0" marL="0">
+              <a:buNone/>
+            </a:pPr>
+            <a:r>
+              <a:rPr lang="en-US" sz="1050" dirty="0">
+                <a:solidFill>
+                  <a:srgbClr val="E0F0FF"/>
+                </a:solidFill>
+                <a:latin typeface="Calibri" pitchFamily="34" charset="0"/>
+                <a:ea typeface="Calibri" pitchFamily="34" charset="-122"/>
+                <a:cs typeface="Calibri" pitchFamily="34" charset="-120"/>
+              </a:rPr>
+              <a:t>Models roads as a weighted graph. Runs BFS/DFS/Dijkstra to find the best route</a:t>
+            </a:r>
+            <a:endParaRPr lang="en-US" sz="1050" dirty="0"/>
+          </a:p>
+        </p:txBody>
+      </p:sp>
+      <p:sp>
+        <p:nvSpPr>
+          <p:cNvPr id="24" name="Shape 22"/>
+          <p:cNvSpPr/>
+          <p:nvPr/>
+        </p:nvSpPr>
+        <p:spPr>
+          <a:xfrm>
+            <a:off x="6711696" y="2926080"/>
+            <a:ext cx="201168" cy="0"/>
+          </a:xfrm>
+          <a:prstGeom prst="line">
+            <a:avLst/>
+          </a:prstGeom>
+          <a:noFill/>
+          <a:ln w="25400">
+            <a:solidFill>
+              <a:srgbClr val="00B4D8"/>
+            </a:solidFill>
+            <a:prstDash val="solid"/>
+          </a:ln>
+        </p:spPr>
+      </p:sp>
+      <p:sp>
+        <p:nvSpPr>
+          <p:cNvPr id="25" name="Shape 23"/>
+          <p:cNvSpPr/>
+          <p:nvPr/>
+        </p:nvSpPr>
+        <p:spPr>
+          <a:xfrm>
+            <a:off x="6912864" y="1143000"/>
+            <a:ext cx="2011680" cy="3566160"/>
+          </a:xfrm>
+          <a:prstGeom prst="rect">
+            <a:avLst/>
+          </a:prstGeom>
+          <a:solidFill>
+            <a:srgbClr val="112B52"/>
+          </a:solidFill>
+          <a:ln/>
+        </p:spPr>
+      </p:sp>
+      <p:sp>
+        <p:nvSpPr>
+          <p:cNvPr id="26" name="Shape 24"/>
+          <p:cNvSpPr/>
+          <p:nvPr/>
+        </p:nvSpPr>
+        <p:spPr>
+          <a:xfrm>
+            <a:off x="6912864" y="1143000"/>
+            <a:ext cx="2011680" cy="548640"/>
           </a:xfrm>
           <a:prstGeom prst="rect">
             <a:avLst/>
@@ -10949,14 +12556,14 @@
       </p:sp>
       <p:sp>
         <p:nvSpPr>
-          <p:cNvPr id="6" name="Text 4"/>
-          <p:cNvSpPr/>
-          <p:nvPr/>
-        </p:nvSpPr>
-        <p:spPr>
-          <a:xfrm>
-            <a:off x="320040" y="1143000"/>
-            <a:ext cx="658368" cy="1115568"/>
+          <p:cNvPr id="27" name="Text 25"/>
+          <p:cNvSpPr/>
+          <p:nvPr/>
+        </p:nvSpPr>
+        <p:spPr>
+          <a:xfrm>
+            <a:off x="6912864" y="1161288"/>
+            <a:ext cx="2011680" cy="274320"/>
           </a:xfrm>
           <a:prstGeom prst="rect">
             <a:avLst/>
@@ -10972,7 +12579,7 @@
               <a:buNone/>
             </a:pPr>
             <a:r>
-              <a:rPr lang="en-US" sz="2800" b="1" dirty="0">
+              <a:rPr lang="en-US" sz="1300" b="1" dirty="0">
                 <a:solidFill>
                   <a:srgbClr val="FFFFFF"/>
                 </a:solidFill>
@@ -10980,7 +12587,85 @@
                 <a:ea typeface="Calibri" pitchFamily="34" charset="-122"/>
                 <a:cs typeface="Calibri" pitchFamily="34" charset="-120"/>
               </a:rPr>
-              <a:t>01</a:t>
+              <a:t>BCS402</a:t>
+            </a:r>
+            <a:endParaRPr lang="en-US" sz="1300" dirty="0"/>
+          </a:p>
+        </p:txBody>
+      </p:sp>
+      <p:sp>
+        <p:nvSpPr>
+          <p:cNvPr id="28" name="Text 26"/>
+          <p:cNvSpPr/>
+          <p:nvPr/>
+        </p:nvSpPr>
+        <p:spPr>
+          <a:xfrm>
+            <a:off x="6912864" y="1417320"/>
+            <a:ext cx="2011680" cy="256032"/>
+          </a:xfrm>
+          <a:prstGeom prst="rect">
+            <a:avLst/>
+          </a:prstGeom>
+          <a:noFill/>
+          <a:ln/>
+        </p:spPr>
+        <p:txBody>
+          <a:bodyPr wrap="square" lIns="0" tIns="0" rIns="0" bIns="0" rtlCol="0" anchor="ctr"/>
+          <a:lstStyle/>
+          <a:p>
+            <a:pPr algn="ctr" indent="0" marL="0">
+              <a:buNone/>
+            </a:pPr>
+            <a:r>
+              <a:rPr lang="en-US" sz="1000" dirty="0">
+                <a:solidFill>
+                  <a:srgbClr val="FFFFFF"/>
+                </a:solidFill>
+                <a:latin typeface="Calibri" pitchFamily="34" charset="0"/>
+                <a:ea typeface="Calibri" pitchFamily="34" charset="-122"/>
+                <a:cs typeface="Calibri" pitchFamily="34" charset="-120"/>
+              </a:rPr>
+              <a:t>Advanced Java</a:t>
+            </a:r>
+            <a:endParaRPr lang="en-US" sz="1000" dirty="0"/>
+          </a:p>
+        </p:txBody>
+      </p:sp>
+      <p:sp>
+        <p:nvSpPr>
+          <p:cNvPr id="29" name="Text 27"/>
+          <p:cNvSpPr/>
+          <p:nvPr/>
+        </p:nvSpPr>
+        <p:spPr>
+          <a:xfrm>
+            <a:off x="7598664" y="1874520"/>
+            <a:ext cx="594360" cy="594360"/>
+          </a:xfrm>
+          <a:prstGeom prst="rect">
+            <a:avLst/>
+          </a:prstGeom>
+          <a:noFill/>
+          <a:ln/>
+        </p:spPr>
+        <p:txBody>
+          <a:bodyPr wrap="square" lIns="0" tIns="0" rIns="0" bIns="0" rtlCol="0" anchor="ctr"/>
+          <a:lstStyle/>
+          <a:p>
+            <a:pPr algn="ctr" indent="0" marL="0">
+              <a:buNone/>
+            </a:pPr>
+            <a:r>
+              <a:rPr lang="en-US" sz="2800" dirty="0">
+                <a:solidFill>
+                  <a:srgbClr val="000000"/>
+                </a:solidFill>
+                <a:latin typeface="Segoe UI Emoji" pitchFamily="34" charset="0"/>
+                <a:ea typeface="Segoe UI Emoji" pitchFamily="34" charset="-122"/>
+                <a:cs typeface="Segoe UI Emoji" pitchFamily="34" charset="-120"/>
+              </a:rPr>
+              <a:t>💻</a:t>
             </a:r>
             <a:endParaRPr lang="en-US" sz="2800" dirty="0"/>
           </a:p>
@@ -10988,707 +12673,99 @@
       </p:sp>
       <p:sp>
         <p:nvSpPr>
-          <p:cNvPr id="7" name="Text 5"/>
-          <p:cNvSpPr/>
-          <p:nvPr/>
-        </p:nvSpPr>
-        <p:spPr>
-          <a:xfrm>
-            <a:off x="1078992" y="1216152"/>
-            <a:ext cx="7205472" cy="274320"/>
-          </a:xfrm>
-          <a:prstGeom prst="rect">
-            <a:avLst/>
-          </a:prstGeom>
-          <a:noFill/>
-          <a:ln/>
-        </p:spPr>
-        <p:txBody>
-          <a:bodyPr wrap="square" lIns="0" tIns="0" rIns="0" bIns="0" rtlCol="0" anchor="ctr"/>
-          <a:lstStyle/>
-          <a:p>
-            <a:pPr indent="0" marL="0">
-              <a:buNone/>
-            </a:pPr>
-            <a:r>
-              <a:rPr lang="en-US" sz="1350" b="1" dirty="0">
-                <a:solidFill>
-                  <a:srgbClr val="1E293B"/>
-                </a:solidFill>
-                <a:latin typeface="Calibri" pitchFamily="34" charset="0"/>
-                <a:ea typeface="Calibri" pitchFamily="34" charset="-122"/>
-                <a:cs typeface="Calibri" pitchFamily="34" charset="-120"/>
-              </a:rPr>
-              <a:t>Nearest Hospital is Best</a:t>
-            </a:r>
-            <a:endParaRPr lang="en-US" sz="1350" dirty="0"/>
-          </a:p>
-        </p:txBody>
-      </p:sp>
-      <p:sp>
-        <p:nvSpPr>
-          <p:cNvPr id="8" name="Text 6"/>
-          <p:cNvSpPr/>
-          <p:nvPr/>
-        </p:nvSpPr>
-        <p:spPr>
-          <a:xfrm>
-            <a:off x="1078992" y="1490472"/>
-            <a:ext cx="7205472" cy="201168"/>
-          </a:xfrm>
-          <a:prstGeom prst="rect">
-            <a:avLst/>
-          </a:prstGeom>
-          <a:noFill/>
-          <a:ln/>
-        </p:spPr>
-        <p:txBody>
-          <a:bodyPr wrap="square" lIns="0" tIns="0" rIns="0" bIns="0" rtlCol="0" anchor="ctr"/>
-          <a:lstStyle/>
-          <a:p>
-            <a:pPr indent="0" marL="0">
-              <a:buNone/>
-            </a:pPr>
-            <a:r>
-              <a:rPr lang="en-US" sz="950" i="1" dirty="0">
-                <a:solidFill>
-                  <a:srgbClr val="64748B"/>
-                </a:solidFill>
-                <a:latin typeface="Calibri" pitchFamily="34" charset="0"/>
-                <a:ea typeface="Calibri" pitchFamily="34" charset="-122"/>
-                <a:cs typeface="Calibri" pitchFamily="34" charset="-120"/>
-              </a:rPr>
-              <a:t>Scenario: Patient at Node 1 (JSSATE)  |  Emergency: GENERAL  |  No ICU</a:t>
-            </a:r>
-            <a:endParaRPr lang="en-US" sz="950" dirty="0"/>
-          </a:p>
-        </p:txBody>
-      </p:sp>
-      <p:sp>
-        <p:nvSpPr>
-          <p:cNvPr id="9" name="Text 7"/>
-          <p:cNvSpPr/>
-          <p:nvPr/>
-        </p:nvSpPr>
-        <p:spPr>
-          <a:xfrm>
-            <a:off x="1078992" y="1691640"/>
-            <a:ext cx="5394960" cy="502920"/>
-          </a:xfrm>
-          <a:prstGeom prst="rect">
-            <a:avLst/>
-          </a:prstGeom>
-          <a:noFill/>
-          <a:ln/>
-        </p:spPr>
-        <p:txBody>
-          <a:bodyPr wrap="square" lIns="0" tIns="0" rIns="0" bIns="0" rtlCol="0" anchor="ctr"/>
-          <a:lstStyle/>
-          <a:p>
-            <a:pPr indent="0" marL="0">
-              <a:buNone/>
-            </a:pPr>
-            <a:r>
-              <a:rPr lang="en-US" sz="1000" dirty="0">
-                <a:solidFill>
-                  <a:srgbClr val="1E293B"/>
-                </a:solidFill>
-                <a:latin typeface="Calibri" pitchFamily="34" charset="0"/>
-                <a:ea typeface="Calibri" pitchFamily="34" charset="-122"/>
-                <a:cs typeface="Calibri" pitchFamily="34" charset="-120"/>
-              </a:rPr>
-              <a:t>Result: BGS Gleneagles (Node 5, 1.2 km) handles GENERAL, has beds, and is the shortest Dijkstra path. System recommends it.</a:t>
+          <p:cNvPr id="30" name="Text 28"/>
+          <p:cNvSpPr/>
+          <p:nvPr/>
+        </p:nvSpPr>
+        <p:spPr>
+          <a:xfrm>
+            <a:off x="7022592" y="2606040"/>
+            <a:ext cx="1792224" cy="2011680"/>
+          </a:xfrm>
+          <a:prstGeom prst="rect">
+            <a:avLst/>
+          </a:prstGeom>
+          <a:noFill/>
+          <a:ln/>
+        </p:spPr>
+        <p:txBody>
+          <a:bodyPr wrap="square" lIns="0" tIns="0" rIns="0" bIns="0" rtlCol="0" anchor="ctr"/>
+          <a:lstStyle/>
+          <a:p>
+            <a:pPr algn="ctr" indent="0" marL="0">
+              <a:buNone/>
+            </a:pPr>
+            <a:r>
+              <a:rPr lang="en-US" sz="1050" dirty="0">
+                <a:solidFill>
+                  <a:srgbClr val="E0F0FF"/>
+                </a:solidFill>
+                <a:latin typeface="Calibri" pitchFamily="34" charset="0"/>
+                <a:ea typeface="Calibri" pitchFamily="34" charset="-122"/>
+                <a:cs typeface="Calibri" pitchFamily="34" charset="-120"/>
+              </a:rPr>
+              <a:t>Builds the full application — OOP classes, Swing UI, Collections, JDBC connector</a:t>
+            </a:r>
+            <a:endParaRPr lang="en-US" sz="1050" dirty="0"/>
+          </a:p>
+        </p:txBody>
+      </p:sp>
+      <p:sp>
+        <p:nvSpPr>
+          <p:cNvPr id="31" name="Shape 29"/>
+          <p:cNvSpPr/>
+          <p:nvPr/>
+        </p:nvSpPr>
+        <p:spPr>
+          <a:xfrm>
+            <a:off x="274320" y="4709160"/>
+            <a:ext cx="8595360" cy="274320"/>
+          </a:xfrm>
+          <a:prstGeom prst="rect">
+            <a:avLst/>
+          </a:prstGeom>
+          <a:solidFill>
+            <a:srgbClr val="193050"/>
+          </a:solidFill>
+          <a:ln/>
+        </p:spPr>
+      </p:sp>
+      <p:sp>
+        <p:nvSpPr>
+          <p:cNvPr id="32" name="Text 30"/>
+          <p:cNvSpPr/>
+          <p:nvPr/>
+        </p:nvSpPr>
+        <p:spPr>
+          <a:xfrm>
+            <a:off x="274320" y="4709160"/>
+            <a:ext cx="8595360" cy="274320"/>
+          </a:xfrm>
+          <a:prstGeom prst="rect">
+            <a:avLst/>
+          </a:prstGeom>
+          <a:noFill/>
+          <a:ln/>
+        </p:spPr>
+        <p:txBody>
+          <a:bodyPr wrap="square" lIns="0" tIns="0" rIns="0" bIns="0" rtlCol="0" anchor="ctr"/>
+          <a:lstStyle/>
+          <a:p>
+            <a:pPr algn="ctr" indent="0" marL="0">
+              <a:buNone/>
+            </a:pPr>
+            <a:r>
+              <a:rPr lang="en-US" sz="1000" b="1" dirty="0">
+                <a:solidFill>
+                  <a:srgbClr val="00B4D8"/>
+                </a:solidFill>
+                <a:latin typeface="Calibri" pitchFamily="34" charset="0"/>
+                <a:ea typeface="Calibri" pitchFamily="34" charset="-122"/>
+                <a:cs typeface="Calibri" pitchFamily="34" charset="-120"/>
+              </a:rPr>
+              <a:t>Algorithm Design defines the WHY  ·  Graph Theory does the routing  ·  DBMS stores everything  ·  Advanced Java builds it all</a:t>
             </a:r>
             <a:endParaRPr lang="en-US" sz="1000" dirty="0"/>
-          </a:p>
-        </p:txBody>
-      </p:sp>
-      <p:sp>
-        <p:nvSpPr>
-          <p:cNvPr id="10" name="Shape 8"/>
-          <p:cNvSpPr/>
-          <p:nvPr/>
-        </p:nvSpPr>
-        <p:spPr>
-          <a:xfrm>
-            <a:off x="6720840" y="1673352"/>
-            <a:ext cx="1938528" cy="438912"/>
-          </a:xfrm>
-          <a:prstGeom prst="roundRect">
-            <a:avLst>
-              <a:gd name="adj" fmla="val 10417"/>
-            </a:avLst>
-          </a:prstGeom>
-          <a:solidFill>
-            <a:srgbClr val="10B981"/>
-          </a:solidFill>
-          <a:ln/>
-        </p:spPr>
-      </p:sp>
-      <p:sp>
-        <p:nvSpPr>
-          <p:cNvPr id="11" name="Text 9"/>
-          <p:cNvSpPr/>
-          <p:nvPr/>
-        </p:nvSpPr>
-        <p:spPr>
-          <a:xfrm>
-            <a:off x="6720840" y="1673352"/>
-            <a:ext cx="1938528" cy="438912"/>
-          </a:xfrm>
-          <a:prstGeom prst="rect">
-            <a:avLst/>
-          </a:prstGeom>
-          <a:noFill/>
-          <a:ln/>
-        </p:spPr>
-        <p:txBody>
-          <a:bodyPr wrap="square" lIns="38100" tIns="38100" rIns="38100" bIns="38100" rtlCol="0" anchor="ctr"/>
-          <a:lstStyle/>
-          <a:p>
-            <a:pPr algn="ctr" indent="0" marL="0">
-              <a:buNone/>
-            </a:pPr>
-            <a:r>
-              <a:rPr lang="en-US" sz="850" dirty="0">
-                <a:solidFill>
-                  <a:srgbClr val="FFFFFF"/>
-                </a:solidFill>
-                <a:latin typeface="Calibri" pitchFamily="34" charset="0"/>
-                <a:ea typeface="Calibri" pitchFamily="34" charset="-122"/>
-                <a:cs typeface="Calibri" pitchFamily="34" charset="-120"/>
-              </a:rPr>
-              <a:t>Shows the system works correctly in the simple case.</a:t>
-            </a:r>
-            <a:endParaRPr lang="en-US" sz="850" dirty="0"/>
-          </a:p>
-        </p:txBody>
-      </p:sp>
-      <p:sp>
-        <p:nvSpPr>
-          <p:cNvPr id="12" name="Shape 10"/>
-          <p:cNvSpPr/>
-          <p:nvPr/>
-        </p:nvSpPr>
-        <p:spPr>
-          <a:xfrm>
-            <a:off x="320040" y="2404872"/>
-            <a:ext cx="8503920" cy="1115568"/>
-          </a:xfrm>
-          <a:prstGeom prst="rect">
-            <a:avLst/>
-          </a:prstGeom>
-          <a:solidFill>
-            <a:srgbClr val="FFFFFF"/>
-          </a:solidFill>
-          <a:ln/>
-          <a:effectLst>
-            <a:outerShdw sx="100000" sy="100000" kx="0" ky="0" algn="bl" rotWithShape="0" blurRad="101600" dist="38100" dir="8100000">
-              <a:srgbClr val="000000">
-                <a:alpha val="12000"/>
-              </a:srgbClr>
-            </a:outerShdw>
-          </a:effectLst>
-        </p:spPr>
-      </p:sp>
-      <p:sp>
-        <p:nvSpPr>
-          <p:cNvPr id="13" name="Shape 11"/>
-          <p:cNvSpPr/>
-          <p:nvPr/>
-        </p:nvSpPr>
-        <p:spPr>
-          <a:xfrm>
-            <a:off x="320040" y="2404872"/>
-            <a:ext cx="658368" cy="1115568"/>
-          </a:xfrm>
-          <a:prstGeom prst="rect">
-            <a:avLst/>
-          </a:prstGeom>
-          <a:solidFill>
-            <a:srgbClr val="F59E0B"/>
-          </a:solidFill>
-          <a:ln/>
-        </p:spPr>
-      </p:sp>
-      <p:sp>
-        <p:nvSpPr>
-          <p:cNvPr id="14" name="Text 12"/>
-          <p:cNvSpPr/>
-          <p:nvPr/>
-        </p:nvSpPr>
-        <p:spPr>
-          <a:xfrm>
-            <a:off x="320040" y="2404872"/>
-            <a:ext cx="658368" cy="1115568"/>
-          </a:xfrm>
-          <a:prstGeom prst="rect">
-            <a:avLst/>
-          </a:prstGeom>
-          <a:noFill/>
-          <a:ln/>
-        </p:spPr>
-        <p:txBody>
-          <a:bodyPr wrap="square" lIns="0" tIns="0" rIns="0" bIns="0" rtlCol="0" anchor="ctr"/>
-          <a:lstStyle/>
-          <a:p>
-            <a:pPr algn="ctr" indent="0" marL="0">
-              <a:buNone/>
-            </a:pPr>
-            <a:r>
-              <a:rPr lang="en-US" sz="2800" b="1" dirty="0">
-                <a:solidFill>
-                  <a:srgbClr val="FFFFFF"/>
-                </a:solidFill>
-                <a:latin typeface="Calibri" pitchFamily="34" charset="0"/>
-                <a:ea typeface="Calibri" pitchFamily="34" charset="-122"/>
-                <a:cs typeface="Calibri" pitchFamily="34" charset="-120"/>
-              </a:rPr>
-              <a:t>02</a:t>
-            </a:r>
-            <a:endParaRPr lang="en-US" sz="2800" dirty="0"/>
-          </a:p>
-        </p:txBody>
-      </p:sp>
-      <p:sp>
-        <p:nvSpPr>
-          <p:cNvPr id="15" name="Text 13"/>
-          <p:cNvSpPr/>
-          <p:nvPr/>
-        </p:nvSpPr>
-        <p:spPr>
-          <a:xfrm>
-            <a:off x="1078992" y="2478024"/>
-            <a:ext cx="7205472" cy="274320"/>
-          </a:xfrm>
-          <a:prstGeom prst="rect">
-            <a:avLst/>
-          </a:prstGeom>
-          <a:noFill/>
-          <a:ln/>
-        </p:spPr>
-        <p:txBody>
-          <a:bodyPr wrap="square" lIns="0" tIns="0" rIns="0" bIns="0" rtlCol="0" anchor="ctr"/>
-          <a:lstStyle/>
-          <a:p>
-            <a:pPr indent="0" marL="0">
-              <a:buNone/>
-            </a:pPr>
-            <a:r>
-              <a:rPr lang="en-US" sz="1350" b="1" dirty="0">
-                <a:solidFill>
-                  <a:srgbClr val="1E293B"/>
-                </a:solidFill>
-                <a:latin typeface="Calibri" pitchFamily="34" charset="0"/>
-                <a:ea typeface="Calibri" pitchFamily="34" charset="-122"/>
-                <a:cs typeface="Calibri" pitchFamily="34" charset="-120"/>
-              </a:rPr>
-              <a:t>Nearest Hospital Lacks ICU</a:t>
-            </a:r>
-            <a:endParaRPr lang="en-US" sz="1350" dirty="0"/>
-          </a:p>
-        </p:txBody>
-      </p:sp>
-      <p:sp>
-        <p:nvSpPr>
-          <p:cNvPr id="16" name="Text 14"/>
-          <p:cNvSpPr/>
-          <p:nvPr/>
-        </p:nvSpPr>
-        <p:spPr>
-          <a:xfrm>
-            <a:off x="1078992" y="2752344"/>
-            <a:ext cx="7205472" cy="201168"/>
-          </a:xfrm>
-          <a:prstGeom prst="rect">
-            <a:avLst/>
-          </a:prstGeom>
-          <a:noFill/>
-          <a:ln/>
-        </p:spPr>
-        <p:txBody>
-          <a:bodyPr wrap="square" lIns="0" tIns="0" rIns="0" bIns="0" rtlCol="0" anchor="ctr"/>
-          <a:lstStyle/>
-          <a:p>
-            <a:pPr indent="0" marL="0">
-              <a:buNone/>
-            </a:pPr>
-            <a:r>
-              <a:rPr lang="en-US" sz="950" i="1" dirty="0">
-                <a:solidFill>
-                  <a:srgbClr val="64748B"/>
-                </a:solidFill>
-                <a:latin typeface="Calibri" pitchFamily="34" charset="0"/>
-                <a:ea typeface="Calibri" pitchFamily="34" charset="-122"/>
-                <a:cs typeface="Calibri" pitchFamily="34" charset="-120"/>
-              </a:rPr>
-              <a:t>Scenario: Patient at Node 1 (JSSATE)  |  Emergency: TRAUMA  |  Needs ICU</a:t>
-            </a:r>
-            <a:endParaRPr lang="en-US" sz="950" dirty="0"/>
-          </a:p>
-        </p:txBody>
-      </p:sp>
-      <p:sp>
-        <p:nvSpPr>
-          <p:cNvPr id="17" name="Text 15"/>
-          <p:cNvSpPr/>
-          <p:nvPr/>
-        </p:nvSpPr>
-        <p:spPr>
-          <a:xfrm>
-            <a:off x="1078992" y="2953512"/>
-            <a:ext cx="5394960" cy="502920"/>
-          </a:xfrm>
-          <a:prstGeom prst="rect">
-            <a:avLst/>
-          </a:prstGeom>
-          <a:noFill/>
-          <a:ln/>
-        </p:spPr>
-        <p:txBody>
-          <a:bodyPr wrap="square" lIns="0" tIns="0" rIns="0" bIns="0" rtlCol="0" anchor="ctr"/>
-          <a:lstStyle/>
-          <a:p>
-            <a:pPr indent="0" marL="0">
-              <a:buNone/>
-            </a:pPr>
-            <a:r>
-              <a:rPr lang="en-US" sz="1000" dirty="0">
-                <a:solidFill>
-                  <a:srgbClr val="1E293B"/>
-                </a:solidFill>
-                <a:latin typeface="Calibri" pitchFamily="34" charset="0"/>
-                <a:ea typeface="Calibri" pitchFamily="34" charset="-122"/>
-                <a:cs typeface="Calibri" pitchFamily="34" charset="-120"/>
-              </a:rPr>
-              <a:t>Result: BGS (1.2 km) has CARDIAC not TRAUMA — filtered out. Sagar Hospital (Node 4, 7.7 km) handles TRAUMA and has ICU — selected.</a:t>
-            </a:r>
-            <a:endParaRPr lang="en-US" sz="1000" dirty="0"/>
-          </a:p>
-        </p:txBody>
-      </p:sp>
-      <p:sp>
-        <p:nvSpPr>
-          <p:cNvPr id="18" name="Shape 16"/>
-          <p:cNvSpPr/>
-          <p:nvPr/>
-        </p:nvSpPr>
-        <p:spPr>
-          <a:xfrm>
-            <a:off x="6720840" y="2935224"/>
-            <a:ext cx="1938528" cy="438912"/>
-          </a:xfrm>
-          <a:prstGeom prst="roundRect">
-            <a:avLst>
-              <a:gd name="adj" fmla="val 10417"/>
-            </a:avLst>
-          </a:prstGeom>
-          <a:solidFill>
-            <a:srgbClr val="F59E0B"/>
-          </a:solidFill>
-          <a:ln/>
-        </p:spPr>
-      </p:sp>
-      <p:sp>
-        <p:nvSpPr>
-          <p:cNvPr id="19" name="Text 17"/>
-          <p:cNvSpPr/>
-          <p:nvPr/>
-        </p:nvSpPr>
-        <p:spPr>
-          <a:xfrm>
-            <a:off x="6720840" y="2935224"/>
-            <a:ext cx="1938528" cy="438912"/>
-          </a:xfrm>
-          <a:prstGeom prst="rect">
-            <a:avLst/>
-          </a:prstGeom>
-          <a:noFill/>
-          <a:ln/>
-        </p:spPr>
-        <p:txBody>
-          <a:bodyPr wrap="square" lIns="38100" tIns="38100" rIns="38100" bIns="38100" rtlCol="0" anchor="ctr"/>
-          <a:lstStyle/>
-          <a:p>
-            <a:pPr algn="ctr" indent="0" marL="0">
-              <a:buNone/>
-            </a:pPr>
-            <a:r>
-              <a:rPr lang="en-US" sz="850" dirty="0">
-                <a:solidFill>
-                  <a:srgbClr val="FFFFFF"/>
-                </a:solidFill>
-                <a:latin typeface="Calibri" pitchFamily="34" charset="0"/>
-                <a:ea typeface="Calibri" pitchFamily="34" charset="-122"/>
-                <a:cs typeface="Calibri" pitchFamily="34" charset="-120"/>
-              </a:rPr>
-              <a:t>Shows why nearest ≠ best. Resource + type check matters.</a:t>
-            </a:r>
-            <a:endParaRPr lang="en-US" sz="850" dirty="0"/>
-          </a:p>
-        </p:txBody>
-      </p:sp>
-      <p:sp>
-        <p:nvSpPr>
-          <p:cNvPr id="20" name="Shape 18"/>
-          <p:cNvSpPr/>
-          <p:nvPr/>
-        </p:nvSpPr>
-        <p:spPr>
-          <a:xfrm>
-            <a:off x="320040" y="3666744"/>
-            <a:ext cx="8503920" cy="1115568"/>
-          </a:xfrm>
-          <a:prstGeom prst="rect">
-            <a:avLst/>
-          </a:prstGeom>
-          <a:solidFill>
-            <a:srgbClr val="FFFFFF"/>
-          </a:solidFill>
-          <a:ln/>
-          <a:effectLst>
-            <a:outerShdw sx="100000" sy="100000" kx="0" ky="0" algn="bl" rotWithShape="0" blurRad="101600" dist="38100" dir="8100000">
-              <a:srgbClr val="000000">
-                <a:alpha val="12000"/>
-              </a:srgbClr>
-            </a:outerShdw>
-          </a:effectLst>
-        </p:spPr>
-      </p:sp>
-      <p:sp>
-        <p:nvSpPr>
-          <p:cNvPr id="21" name="Shape 19"/>
-          <p:cNvSpPr/>
-          <p:nvPr/>
-        </p:nvSpPr>
-        <p:spPr>
-          <a:xfrm>
-            <a:off x="320040" y="3666744"/>
-            <a:ext cx="658368" cy="1115568"/>
-          </a:xfrm>
-          <a:prstGeom prst="rect">
-            <a:avLst/>
-          </a:prstGeom>
-          <a:solidFill>
-            <a:srgbClr val="00B4D8"/>
-          </a:solidFill>
-          <a:ln/>
-        </p:spPr>
-      </p:sp>
-      <p:sp>
-        <p:nvSpPr>
-          <p:cNvPr id="22" name="Text 20"/>
-          <p:cNvSpPr/>
-          <p:nvPr/>
-        </p:nvSpPr>
-        <p:spPr>
-          <a:xfrm>
-            <a:off x="320040" y="3666744"/>
-            <a:ext cx="658368" cy="1115568"/>
-          </a:xfrm>
-          <a:prstGeom prst="rect">
-            <a:avLst/>
-          </a:prstGeom>
-          <a:noFill/>
-          <a:ln/>
-        </p:spPr>
-        <p:txBody>
-          <a:bodyPr wrap="square" lIns="0" tIns="0" rIns="0" bIns="0" rtlCol="0" anchor="ctr"/>
-          <a:lstStyle/>
-          <a:p>
-            <a:pPr algn="ctr" indent="0" marL="0">
-              <a:buNone/>
-            </a:pPr>
-            <a:r>
-              <a:rPr lang="en-US" sz="2800" b="1" dirty="0">
-                <a:solidFill>
-                  <a:srgbClr val="FFFFFF"/>
-                </a:solidFill>
-                <a:latin typeface="Calibri" pitchFamily="34" charset="0"/>
-                <a:ea typeface="Calibri" pitchFamily="34" charset="-122"/>
-                <a:cs typeface="Calibri" pitchFamily="34" charset="-120"/>
-              </a:rPr>
-              <a:t>03</a:t>
-            </a:r>
-            <a:endParaRPr lang="en-US" sz="2800" dirty="0"/>
-          </a:p>
-        </p:txBody>
-      </p:sp>
-      <p:sp>
-        <p:nvSpPr>
-          <p:cNvPr id="23" name="Text 21"/>
-          <p:cNvSpPr/>
-          <p:nvPr/>
-        </p:nvSpPr>
-        <p:spPr>
-          <a:xfrm>
-            <a:off x="1078992" y="3739896"/>
-            <a:ext cx="7205472" cy="274320"/>
-          </a:xfrm>
-          <a:prstGeom prst="rect">
-            <a:avLst/>
-          </a:prstGeom>
-          <a:noFill/>
-          <a:ln/>
-        </p:spPr>
-        <p:txBody>
-          <a:bodyPr wrap="square" lIns="0" tIns="0" rIns="0" bIns="0" rtlCol="0" anchor="ctr"/>
-          <a:lstStyle/>
-          <a:p>
-            <a:pPr indent="0" marL="0">
-              <a:buNone/>
-            </a:pPr>
-            <a:r>
-              <a:rPr lang="en-US" sz="1350" b="1" dirty="0">
-                <a:solidFill>
-                  <a:srgbClr val="1E293B"/>
-                </a:solidFill>
-                <a:latin typeface="Calibri" pitchFamily="34" charset="0"/>
-                <a:ea typeface="Calibri" pitchFamily="34" charset="-122"/>
-                <a:cs typeface="Calibri" pitchFamily="34" charset="-120"/>
-              </a:rPr>
-              <a:t>Multiple Valid Hospitals — Dijkstra Decides</a:t>
-            </a:r>
-            <a:endParaRPr lang="en-US" sz="1350" dirty="0"/>
-          </a:p>
-        </p:txBody>
-      </p:sp>
-      <p:sp>
-        <p:nvSpPr>
-          <p:cNvPr id="24" name="Text 22"/>
-          <p:cNvSpPr/>
-          <p:nvPr/>
-        </p:nvSpPr>
-        <p:spPr>
-          <a:xfrm>
-            <a:off x="1078992" y="4014216"/>
-            <a:ext cx="7205472" cy="201168"/>
-          </a:xfrm>
-          <a:prstGeom prst="rect">
-            <a:avLst/>
-          </a:prstGeom>
-          <a:noFill/>
-          <a:ln/>
-        </p:spPr>
-        <p:txBody>
-          <a:bodyPr wrap="square" lIns="0" tIns="0" rIns="0" bIns="0" rtlCol="0" anchor="ctr"/>
-          <a:lstStyle/>
-          <a:p>
-            <a:pPr indent="0" marL="0">
-              <a:buNone/>
-            </a:pPr>
-            <a:r>
-              <a:rPr lang="en-US" sz="950" i="1" dirty="0">
-                <a:solidFill>
-                  <a:srgbClr val="64748B"/>
-                </a:solidFill>
-                <a:latin typeface="Calibri" pitchFamily="34" charset="0"/>
-                <a:ea typeface="Calibri" pitchFamily="34" charset="-122"/>
-                <a:cs typeface="Calibri" pitchFamily="34" charset="-120"/>
-              </a:rPr>
-              <a:t>Scenario: Patient at Node 10 (BSK)  |  Emergency: CARDIAC  |  Needs ICU</a:t>
-            </a:r>
-            <a:endParaRPr lang="en-US" sz="950" dirty="0"/>
-          </a:p>
-        </p:txBody>
-      </p:sp>
-      <p:sp>
-        <p:nvSpPr>
-          <p:cNvPr id="25" name="Text 23"/>
-          <p:cNvSpPr/>
-          <p:nvPr/>
-        </p:nvSpPr>
-        <p:spPr>
-          <a:xfrm>
-            <a:off x="1078992" y="4215384"/>
-            <a:ext cx="5394960" cy="502920"/>
-          </a:xfrm>
-          <a:prstGeom prst="rect">
-            <a:avLst/>
-          </a:prstGeom>
-          <a:noFill/>
-          <a:ln/>
-        </p:spPr>
-        <p:txBody>
-          <a:bodyPr wrap="square" lIns="0" tIns="0" rIns="0" bIns="0" rtlCol="0" anchor="ctr"/>
-          <a:lstStyle/>
-          <a:p>
-            <a:pPr indent="0" marL="0">
-              <a:buNone/>
-            </a:pPr>
-            <a:r>
-              <a:rPr lang="en-US" sz="1000" dirty="0">
-                <a:solidFill>
-                  <a:srgbClr val="1E293B"/>
-                </a:solidFill>
-                <a:latin typeface="Calibri" pitchFamily="34" charset="0"/>
-                <a:ea typeface="Calibri" pitchFamily="34" charset="-122"/>
-                <a:cs typeface="Calibri" pitchFamily="34" charset="-120"/>
-              </a:rPr>
-              <a:t>Result: BGS (Node 5), Apollo (Node 11), and Fortis (Node 13) all handle CARDIAC with ICU. Dijkstra computes: BGS=9.2km, Apollo=5.5km, Fortis=5.8km. Apollo wins.</a:t>
-            </a:r>
-            <a:endParaRPr lang="en-US" sz="1000" dirty="0"/>
-          </a:p>
-        </p:txBody>
-      </p:sp>
-      <p:sp>
-        <p:nvSpPr>
-          <p:cNvPr id="26" name="Shape 24"/>
-          <p:cNvSpPr/>
-          <p:nvPr/>
-        </p:nvSpPr>
-        <p:spPr>
-          <a:xfrm>
-            <a:off x="6720840" y="4197096"/>
-            <a:ext cx="1938528" cy="438912"/>
-          </a:xfrm>
-          <a:prstGeom prst="roundRect">
-            <a:avLst>
-              <a:gd name="adj" fmla="val 10417"/>
-            </a:avLst>
-          </a:prstGeom>
-          <a:solidFill>
-            <a:srgbClr val="00B4D8"/>
-          </a:solidFill>
-          <a:ln/>
-        </p:spPr>
-      </p:sp>
-      <p:sp>
-        <p:nvSpPr>
-          <p:cNvPr id="27" name="Text 25"/>
-          <p:cNvSpPr/>
-          <p:nvPr/>
-        </p:nvSpPr>
-        <p:spPr>
-          <a:xfrm>
-            <a:off x="6720840" y="4197096"/>
-            <a:ext cx="1938528" cy="438912"/>
-          </a:xfrm>
-          <a:prstGeom prst="rect">
-            <a:avLst/>
-          </a:prstGeom>
-          <a:noFill/>
-          <a:ln/>
-        </p:spPr>
-        <p:txBody>
-          <a:bodyPr wrap="square" lIns="38100" tIns="38100" rIns="38100" bIns="38100" rtlCol="0" anchor="ctr"/>
-          <a:lstStyle/>
-          <a:p>
-            <a:pPr algn="ctr" indent="0" marL="0">
-              <a:buNone/>
-            </a:pPr>
-            <a:r>
-              <a:rPr lang="en-US" sz="850" dirty="0">
-                <a:solidFill>
-                  <a:srgbClr val="FFFFFF"/>
-                </a:solidFill>
-                <a:latin typeface="Calibri" pitchFamily="34" charset="0"/>
-                <a:ea typeface="Calibri" pitchFamily="34" charset="-122"/>
-                <a:cs typeface="Calibri" pitchFamily="34" charset="-120"/>
-              </a:rPr>
-              <a:t>Shows Dijkstra's role clearly. Best use case for viva.</a:t>
-            </a:r>
-            <a:endParaRPr lang="en-US" sz="850" dirty="0"/>
           </a:p>
         </p:txBody>
       </p:sp>

</xml_diff>